<commit_message>
Update docs and improve XGBoost/LightGBM explanations
- README: add multi-model, alarm engine, ECharts sections
- ARCHITECTURE: add alarm engine chapter, update for v0.2.0
- presentation.html: add 3 new slides (multi-model, alarm, trends)
- scoring: z-score based deviation diagnosis for XGB/LightGBM
- train: store per-class feature statistics for baseline comparison
- Dashboard: parse both tree and XGB/LightGBM explanation formats
</commit_message>
<xml_diff>
--- a/doc/iHealthSim.pptx
+++ b/doc/iHealthSim.pptx
@@ -5,25 +5,25 @@
     <p:sldMasterId id="2147483648" r:id="rId1"/>
   </p:sldMasterIdLst>
   <p:sldIdLst>
-    <p:sldId id="256" r:id="rId2"/>
-    <p:sldId id="257" r:id="rId3"/>
-    <p:sldId id="258" r:id="rId4"/>
-    <p:sldId id="259" r:id="rId5"/>
-    <p:sldId id="260" r:id="rId6"/>
-    <p:sldId id="261" r:id="rId7"/>
-    <p:sldId id="262" r:id="rId8"/>
-    <p:sldId id="263" r:id="rId9"/>
-    <p:sldId id="264" r:id="rId10"/>
-    <p:sldId id="265" r:id="rId11"/>
-    <p:sldId id="266" r:id="rId12"/>
-    <p:sldId id="267" r:id="rId13"/>
-    <p:sldId id="268" r:id="rId14"/>
-    <p:sldId id="269" r:id="rId15"/>
-    <p:sldId id="270" r:id="rId16"/>
-    <p:sldId id="271" r:id="rId17"/>
-    <p:sldId id="272" r:id="rId18"/>
+    <p:sldId id="256" r:id="rId7"/>
+    <p:sldId id="257" r:id="rId8"/>
+    <p:sldId id="258" r:id="rId9"/>
+    <p:sldId id="259" r:id="rId10"/>
+    <p:sldId id="260" r:id="rId11"/>
+    <p:sldId id="261" r:id="rId12"/>
+    <p:sldId id="262" r:id="rId13"/>
+    <p:sldId id="263" r:id="rId14"/>
+    <p:sldId id="264" r:id="rId15"/>
+    <p:sldId id="265" r:id="rId16"/>
+    <p:sldId id="266" r:id="rId17"/>
+    <p:sldId id="267" r:id="rId18"/>
+    <p:sldId id="268" r:id="rId19"/>
+    <p:sldId id="269" r:id="rId20"/>
+    <p:sldId id="270" r:id="rId21"/>
+    <p:sldId id="271" r:id="rId22"/>
+    <p:sldId id="272" r:id="rId23"/>
   </p:sldIdLst>
-  <p:sldSz cx="12192000" cy="6858000"/>
+  <p:sldSz cx="12191695" cy="6858000" type="screen4x3"/>
   <p:notesSz cx="6858000" cy="9144000"/>
   <p:defaultTextStyle>
     <a:defPPr>
@@ -120,31 +120,7 @@
       </a:defRPr>
     </a:lvl9pPr>
   </p:defaultTextStyle>
-  <p:extLst>
-    <p:ext uri="{EFAFB233-063F-42B5-8137-9DF3F51BA10A}">
-      <p15:sldGuideLst xmlns:p15="http://schemas.microsoft.com/office/powerpoint/2012/main">
-        <p15:guide id="1" orient="horz" pos="2160">
-          <p15:clr>
-            <a:srgbClr val="A4A3A4"/>
-          </p15:clr>
-        </p15:guide>
-        <p15:guide id="2" pos="2880">
-          <p15:clr>
-            <a:srgbClr val="A4A3A4"/>
-          </p15:clr>
-        </p15:guide>
-      </p15:sldGuideLst>
-    </p:ext>
-  </p:extLst>
 </p:presentation>
-</file>
-
-<file path=ppt/revisionInfo.xml><?xml version="1.0" encoding="utf-8"?>
-<p1510:revInfo xmlns:a="http://schemas.openxmlformats.org/drawingml/2006/main" xmlns:r="http://schemas.openxmlformats.org/officeDocument/2006/relationships" xmlns:p1510="http://schemas.microsoft.com/office/powerpoint/2015/10/main">
-  <p1510:revLst>
-    <p1510:client id="{0B6BE154-6BB9-D44C-9111-6AA3FF5780FC}" v="2" dt="2026-05-25T05:54:47.056"/>
-  </p1510:revLst>
-</p1510:revInfo>
 </file>
 
 <file path=ppt/slideLayouts/slideLayout1.xml><?xml version="1.0" encoding="utf-8"?>
@@ -185,9 +161,10 @@
           <a:lstStyle/>
           <a:p>
             <a:r>
-              <a:rPr lang="en-US"/>
+              <a:rPr lang="en-US" smtClean="0"/>
               <a:t>Click to edit Master title style</a:t>
             </a:r>
+            <a:endParaRPr lang="en-US"/>
           </a:p>
         </p:txBody>
       </p:sp>
@@ -303,9 +280,10 @@
           </a:lstStyle>
           <a:p>
             <a:r>
-              <a:rPr lang="en-US"/>
+              <a:rPr lang="en-US" smtClean="0"/>
               <a:t>Click to edit Master subtitle style</a:t>
             </a:r>
+            <a:endParaRPr lang="en-US"/>
           </a:p>
         </p:txBody>
       </p:sp>
@@ -326,7 +304,7 @@
           <a:p>
             <a:fld id="{5BCAD085-E8A6-8845-BD4E-CB4CCA059FC4}" type="datetimeFigureOut">
               <a:rPr lang="en-US" smtClean="0"/>
-              <a:t>5/25/26</a:t>
+              <a:t>1/27/13</a:t>
             </a:fld>
             <a:endParaRPr lang="en-US"/>
           </a:p>
@@ -420,9 +398,10 @@
           <a:lstStyle/>
           <a:p>
             <a:r>
-              <a:rPr lang="en-US"/>
+              <a:rPr lang="en-US" smtClean="0"/>
               <a:t>Click to edit Master title style</a:t>
             </a:r>
+            <a:endParaRPr lang="en-US"/>
           </a:p>
         </p:txBody>
       </p:sp>
@@ -443,37 +422,38 @@
           <a:p>
             <a:pPr lvl="0"/>
             <a:r>
-              <a:rPr lang="en-US"/>
+              <a:rPr lang="en-US" smtClean="0"/>
               <a:t>Click to edit Master text styles</a:t>
             </a:r>
           </a:p>
           <a:p>
             <a:pPr lvl="1"/>
             <a:r>
-              <a:rPr lang="en-US"/>
+              <a:rPr lang="en-US" smtClean="0"/>
               <a:t>Second level</a:t>
             </a:r>
           </a:p>
           <a:p>
             <a:pPr lvl="2"/>
             <a:r>
-              <a:rPr lang="en-US"/>
+              <a:rPr lang="en-US" smtClean="0"/>
               <a:t>Third level</a:t>
             </a:r>
           </a:p>
           <a:p>
             <a:pPr lvl="3"/>
             <a:r>
-              <a:rPr lang="en-US"/>
+              <a:rPr lang="en-US" smtClean="0"/>
               <a:t>Fourth level</a:t>
             </a:r>
           </a:p>
           <a:p>
             <a:pPr lvl="4"/>
             <a:r>
-              <a:rPr lang="en-US"/>
+              <a:rPr lang="en-US" smtClean="0"/>
               <a:t>Fifth level</a:t>
             </a:r>
+            <a:endParaRPr lang="en-US"/>
           </a:p>
         </p:txBody>
       </p:sp>
@@ -494,7 +474,7 @@
           <a:p>
             <a:fld id="{5BCAD085-E8A6-8845-BD4E-CB4CCA059FC4}" type="datetimeFigureOut">
               <a:rPr lang="en-US" smtClean="0"/>
-              <a:t>5/25/26</a:t>
+              <a:t>1/27/13</a:t>
             </a:fld>
             <a:endParaRPr lang="en-US"/>
           </a:p>
@@ -593,9 +573,10 @@
           <a:lstStyle/>
           <a:p>
             <a:r>
-              <a:rPr lang="en-US"/>
+              <a:rPr lang="en-US" smtClean="0"/>
               <a:t>Click to edit Master title style</a:t>
             </a:r>
+            <a:endParaRPr lang="en-US"/>
           </a:p>
         </p:txBody>
       </p:sp>
@@ -621,37 +602,38 @@
           <a:p>
             <a:pPr lvl="0"/>
             <a:r>
-              <a:rPr lang="en-US"/>
+              <a:rPr lang="en-US" smtClean="0"/>
               <a:t>Click to edit Master text styles</a:t>
             </a:r>
           </a:p>
           <a:p>
             <a:pPr lvl="1"/>
             <a:r>
-              <a:rPr lang="en-US"/>
+              <a:rPr lang="en-US" smtClean="0"/>
               <a:t>Second level</a:t>
             </a:r>
           </a:p>
           <a:p>
             <a:pPr lvl="2"/>
             <a:r>
-              <a:rPr lang="en-US"/>
+              <a:rPr lang="en-US" smtClean="0"/>
               <a:t>Third level</a:t>
             </a:r>
           </a:p>
           <a:p>
             <a:pPr lvl="3"/>
             <a:r>
-              <a:rPr lang="en-US"/>
+              <a:rPr lang="en-US" smtClean="0"/>
               <a:t>Fourth level</a:t>
             </a:r>
           </a:p>
           <a:p>
             <a:pPr lvl="4"/>
             <a:r>
-              <a:rPr lang="en-US"/>
+              <a:rPr lang="en-US" smtClean="0"/>
               <a:t>Fifth level</a:t>
             </a:r>
+            <a:endParaRPr lang="en-US"/>
           </a:p>
         </p:txBody>
       </p:sp>
@@ -672,7 +654,7 @@
           <a:p>
             <a:fld id="{5BCAD085-E8A6-8845-BD4E-CB4CCA059FC4}" type="datetimeFigureOut">
               <a:rPr lang="en-US" smtClean="0"/>
-              <a:t>5/25/26</a:t>
+              <a:t>1/27/13</a:t>
             </a:fld>
             <a:endParaRPr lang="en-US"/>
           </a:p>
@@ -766,9 +748,10 @@
           <a:lstStyle/>
           <a:p>
             <a:r>
-              <a:rPr lang="en-US"/>
+              <a:rPr lang="en-US" smtClean="0"/>
               <a:t>Click to edit Master title style</a:t>
             </a:r>
+            <a:endParaRPr lang="en-US"/>
           </a:p>
         </p:txBody>
       </p:sp>
@@ -789,37 +772,38 @@
           <a:p>
             <a:pPr lvl="0"/>
             <a:r>
-              <a:rPr lang="en-US"/>
+              <a:rPr lang="en-US" smtClean="0"/>
               <a:t>Click to edit Master text styles</a:t>
             </a:r>
           </a:p>
           <a:p>
             <a:pPr lvl="1"/>
             <a:r>
-              <a:rPr lang="en-US"/>
+              <a:rPr lang="en-US" smtClean="0"/>
               <a:t>Second level</a:t>
             </a:r>
           </a:p>
           <a:p>
             <a:pPr lvl="2"/>
             <a:r>
-              <a:rPr lang="en-US"/>
+              <a:rPr lang="en-US" smtClean="0"/>
               <a:t>Third level</a:t>
             </a:r>
           </a:p>
           <a:p>
             <a:pPr lvl="3"/>
             <a:r>
-              <a:rPr lang="en-US"/>
+              <a:rPr lang="en-US" smtClean="0"/>
               <a:t>Fourth level</a:t>
             </a:r>
           </a:p>
           <a:p>
             <a:pPr lvl="4"/>
             <a:r>
-              <a:rPr lang="en-US"/>
+              <a:rPr lang="en-US" smtClean="0"/>
               <a:t>Fifth level</a:t>
             </a:r>
+            <a:endParaRPr lang="en-US"/>
           </a:p>
         </p:txBody>
       </p:sp>
@@ -840,7 +824,7 @@
           <a:p>
             <a:fld id="{5BCAD085-E8A6-8845-BD4E-CB4CCA059FC4}" type="datetimeFigureOut">
               <a:rPr lang="en-US" smtClean="0"/>
-              <a:t>5/25/26</a:t>
+              <a:t>1/27/13</a:t>
             </a:fld>
             <a:endParaRPr lang="en-US"/>
           </a:p>
@@ -943,9 +927,10 @@
           </a:lstStyle>
           <a:p>
             <a:r>
-              <a:rPr lang="en-US"/>
+              <a:rPr lang="en-US" smtClean="0"/>
               <a:t>Click to edit Master title style</a:t>
             </a:r>
+            <a:endParaRPr lang="en-US"/>
           </a:p>
         </p:txBody>
       </p:sp>
@@ -1062,7 +1047,7 @@
           <a:p>
             <a:pPr lvl="0"/>
             <a:r>
-              <a:rPr lang="en-US"/>
+              <a:rPr lang="en-US" smtClean="0"/>
               <a:t>Click to edit Master text styles</a:t>
             </a:r>
           </a:p>
@@ -1085,7 +1070,7 @@
           <a:p>
             <a:fld id="{5BCAD085-E8A6-8845-BD4E-CB4CCA059FC4}" type="datetimeFigureOut">
               <a:rPr lang="en-US" smtClean="0"/>
-              <a:t>5/25/26</a:t>
+              <a:t>1/27/13</a:t>
             </a:fld>
             <a:endParaRPr lang="en-US"/>
           </a:p>
@@ -1179,9 +1164,10 @@
           <a:lstStyle/>
           <a:p>
             <a:r>
-              <a:rPr lang="en-US"/>
+              <a:rPr lang="en-US" smtClean="0"/>
               <a:t>Click to edit Master title style</a:t>
             </a:r>
+            <a:endParaRPr lang="en-US"/>
           </a:p>
         </p:txBody>
       </p:sp>
@@ -1235,37 +1221,38 @@
           <a:p>
             <a:pPr lvl="0"/>
             <a:r>
-              <a:rPr lang="en-US"/>
+              <a:rPr lang="en-US" smtClean="0"/>
               <a:t>Click to edit Master text styles</a:t>
             </a:r>
           </a:p>
           <a:p>
             <a:pPr lvl="1"/>
             <a:r>
-              <a:rPr lang="en-US"/>
+              <a:rPr lang="en-US" smtClean="0"/>
               <a:t>Second level</a:t>
             </a:r>
           </a:p>
           <a:p>
             <a:pPr lvl="2"/>
             <a:r>
-              <a:rPr lang="en-US"/>
+              <a:rPr lang="en-US" smtClean="0"/>
               <a:t>Third level</a:t>
             </a:r>
           </a:p>
           <a:p>
             <a:pPr lvl="3"/>
             <a:r>
-              <a:rPr lang="en-US"/>
+              <a:rPr lang="en-US" smtClean="0"/>
               <a:t>Fourth level</a:t>
             </a:r>
           </a:p>
           <a:p>
             <a:pPr lvl="4"/>
             <a:r>
-              <a:rPr lang="en-US"/>
+              <a:rPr lang="en-US" smtClean="0"/>
               <a:t>Fifth level</a:t>
             </a:r>
+            <a:endParaRPr lang="en-US"/>
           </a:p>
         </p:txBody>
       </p:sp>
@@ -1319,37 +1306,38 @@
           <a:p>
             <a:pPr lvl="0"/>
             <a:r>
-              <a:rPr lang="en-US"/>
+              <a:rPr lang="en-US" smtClean="0"/>
               <a:t>Click to edit Master text styles</a:t>
             </a:r>
           </a:p>
           <a:p>
             <a:pPr lvl="1"/>
             <a:r>
-              <a:rPr lang="en-US"/>
+              <a:rPr lang="en-US" smtClean="0"/>
               <a:t>Second level</a:t>
             </a:r>
           </a:p>
           <a:p>
             <a:pPr lvl="2"/>
             <a:r>
-              <a:rPr lang="en-US"/>
+              <a:rPr lang="en-US" smtClean="0"/>
               <a:t>Third level</a:t>
             </a:r>
           </a:p>
           <a:p>
             <a:pPr lvl="3"/>
             <a:r>
-              <a:rPr lang="en-US"/>
+              <a:rPr lang="en-US" smtClean="0"/>
               <a:t>Fourth level</a:t>
             </a:r>
           </a:p>
           <a:p>
             <a:pPr lvl="4"/>
             <a:r>
-              <a:rPr lang="en-US"/>
+              <a:rPr lang="en-US" smtClean="0"/>
               <a:t>Fifth level</a:t>
             </a:r>
+            <a:endParaRPr lang="en-US"/>
           </a:p>
         </p:txBody>
       </p:sp>
@@ -1370,7 +1358,7 @@
           <a:p>
             <a:fld id="{5BCAD085-E8A6-8845-BD4E-CB4CCA059FC4}" type="datetimeFigureOut">
               <a:rPr lang="en-US" smtClean="0"/>
-              <a:t>5/25/26</a:t>
+              <a:t>1/27/13</a:t>
             </a:fld>
             <a:endParaRPr lang="en-US"/>
           </a:p>
@@ -1468,9 +1456,10 @@
           </a:lstStyle>
           <a:p>
             <a:r>
-              <a:rPr lang="en-US"/>
+              <a:rPr lang="en-US" smtClean="0"/>
               <a:t>Click to edit Master title style</a:t>
             </a:r>
+            <a:endParaRPr lang="en-US"/>
           </a:p>
         </p:txBody>
       </p:sp>
@@ -1533,7 +1522,7 @@
           <a:p>
             <a:pPr lvl="0"/>
             <a:r>
-              <a:rPr lang="en-US"/>
+              <a:rPr lang="en-US" smtClean="0"/>
               <a:t>Click to edit Master text styles</a:t>
             </a:r>
           </a:p>
@@ -1589,37 +1578,38 @@
           <a:p>
             <a:pPr lvl="0"/>
             <a:r>
-              <a:rPr lang="en-US"/>
+              <a:rPr lang="en-US" smtClean="0"/>
               <a:t>Click to edit Master text styles</a:t>
             </a:r>
           </a:p>
           <a:p>
             <a:pPr lvl="1"/>
             <a:r>
-              <a:rPr lang="en-US"/>
+              <a:rPr lang="en-US" smtClean="0"/>
               <a:t>Second level</a:t>
             </a:r>
           </a:p>
           <a:p>
             <a:pPr lvl="2"/>
             <a:r>
-              <a:rPr lang="en-US"/>
+              <a:rPr lang="en-US" smtClean="0"/>
               <a:t>Third level</a:t>
             </a:r>
           </a:p>
           <a:p>
             <a:pPr lvl="3"/>
             <a:r>
-              <a:rPr lang="en-US"/>
+              <a:rPr lang="en-US" smtClean="0"/>
               <a:t>Fourth level</a:t>
             </a:r>
           </a:p>
           <a:p>
             <a:pPr lvl="4"/>
             <a:r>
-              <a:rPr lang="en-US"/>
+              <a:rPr lang="en-US" smtClean="0"/>
               <a:t>Fifth level</a:t>
             </a:r>
+            <a:endParaRPr lang="en-US"/>
           </a:p>
         </p:txBody>
       </p:sp>
@@ -1682,7 +1672,7 @@
           <a:p>
             <a:pPr lvl="0"/>
             <a:r>
-              <a:rPr lang="en-US"/>
+              <a:rPr lang="en-US" smtClean="0"/>
               <a:t>Click to edit Master text styles</a:t>
             </a:r>
           </a:p>
@@ -1738,37 +1728,38 @@
           <a:p>
             <a:pPr lvl="0"/>
             <a:r>
-              <a:rPr lang="en-US"/>
+              <a:rPr lang="en-US" smtClean="0"/>
               <a:t>Click to edit Master text styles</a:t>
             </a:r>
           </a:p>
           <a:p>
             <a:pPr lvl="1"/>
             <a:r>
-              <a:rPr lang="en-US"/>
+              <a:rPr lang="en-US" smtClean="0"/>
               <a:t>Second level</a:t>
             </a:r>
           </a:p>
           <a:p>
             <a:pPr lvl="2"/>
             <a:r>
-              <a:rPr lang="en-US"/>
+              <a:rPr lang="en-US" smtClean="0"/>
               <a:t>Third level</a:t>
             </a:r>
           </a:p>
           <a:p>
             <a:pPr lvl="3"/>
             <a:r>
-              <a:rPr lang="en-US"/>
+              <a:rPr lang="en-US" smtClean="0"/>
               <a:t>Fourth level</a:t>
             </a:r>
           </a:p>
           <a:p>
             <a:pPr lvl="4"/>
             <a:r>
-              <a:rPr lang="en-US"/>
+              <a:rPr lang="en-US" smtClean="0"/>
               <a:t>Fifth level</a:t>
             </a:r>
+            <a:endParaRPr lang="en-US"/>
           </a:p>
         </p:txBody>
       </p:sp>
@@ -1789,7 +1780,7 @@
           <a:p>
             <a:fld id="{5BCAD085-E8A6-8845-BD4E-CB4CCA059FC4}" type="datetimeFigureOut">
               <a:rPr lang="en-US" smtClean="0"/>
-              <a:t>5/25/26</a:t>
+              <a:t>1/27/13</a:t>
             </a:fld>
             <a:endParaRPr lang="en-US"/>
           </a:p>
@@ -1883,9 +1874,10 @@
           <a:lstStyle/>
           <a:p>
             <a:r>
-              <a:rPr lang="en-US"/>
+              <a:rPr lang="en-US" smtClean="0"/>
               <a:t>Click to edit Master title style</a:t>
             </a:r>
+            <a:endParaRPr lang="en-US"/>
           </a:p>
         </p:txBody>
       </p:sp>
@@ -1906,7 +1898,7 @@
           <a:p>
             <a:fld id="{5BCAD085-E8A6-8845-BD4E-CB4CCA059FC4}" type="datetimeFigureOut">
               <a:rPr lang="en-US" smtClean="0"/>
-              <a:t>5/25/26</a:t>
+              <a:t>1/27/13</a:t>
             </a:fld>
             <a:endParaRPr lang="en-US"/>
           </a:p>
@@ -2001,7 +1993,7 @@
           <a:p>
             <a:fld id="{5BCAD085-E8A6-8845-BD4E-CB4CCA059FC4}" type="datetimeFigureOut">
               <a:rPr lang="en-US" smtClean="0"/>
-              <a:t>5/25/26</a:t>
+              <a:t>1/27/13</a:t>
             </a:fld>
             <a:endParaRPr lang="en-US"/>
           </a:p>
@@ -2104,9 +2096,10 @@
           </a:lstStyle>
           <a:p>
             <a:r>
-              <a:rPr lang="en-US"/>
+              <a:rPr lang="en-US" smtClean="0"/>
               <a:t>Click to edit Master title style</a:t>
             </a:r>
+            <a:endParaRPr lang="en-US"/>
           </a:p>
         </p:txBody>
       </p:sp>
@@ -2160,37 +2153,38 @@
           <a:p>
             <a:pPr lvl="0"/>
             <a:r>
-              <a:rPr lang="en-US"/>
+              <a:rPr lang="en-US" smtClean="0"/>
               <a:t>Click to edit Master text styles</a:t>
             </a:r>
           </a:p>
           <a:p>
             <a:pPr lvl="1"/>
             <a:r>
-              <a:rPr lang="en-US"/>
+              <a:rPr lang="en-US" smtClean="0"/>
               <a:t>Second level</a:t>
             </a:r>
           </a:p>
           <a:p>
             <a:pPr lvl="2"/>
             <a:r>
-              <a:rPr lang="en-US"/>
+              <a:rPr lang="en-US" smtClean="0"/>
               <a:t>Third level</a:t>
             </a:r>
           </a:p>
           <a:p>
             <a:pPr lvl="3"/>
             <a:r>
-              <a:rPr lang="en-US"/>
+              <a:rPr lang="en-US" smtClean="0"/>
               <a:t>Fourth level</a:t>
             </a:r>
           </a:p>
           <a:p>
             <a:pPr lvl="4"/>
             <a:r>
-              <a:rPr lang="en-US"/>
+              <a:rPr lang="en-US" smtClean="0"/>
               <a:t>Fifth level</a:t>
             </a:r>
+            <a:endParaRPr lang="en-US"/>
           </a:p>
         </p:txBody>
       </p:sp>
@@ -2253,7 +2247,7 @@
           <a:p>
             <a:pPr lvl="0"/>
             <a:r>
-              <a:rPr lang="en-US"/>
+              <a:rPr lang="en-US" smtClean="0"/>
               <a:t>Click to edit Master text styles</a:t>
             </a:r>
           </a:p>
@@ -2276,7 +2270,7 @@
           <a:p>
             <a:fld id="{5BCAD085-E8A6-8845-BD4E-CB4CCA059FC4}" type="datetimeFigureOut">
               <a:rPr lang="en-US" smtClean="0"/>
-              <a:t>5/25/26</a:t>
+              <a:t>1/27/13</a:t>
             </a:fld>
             <a:endParaRPr lang="en-US"/>
           </a:p>
@@ -2379,9 +2373,10 @@
           </a:lstStyle>
           <a:p>
             <a:r>
-              <a:rPr lang="en-US"/>
+              <a:rPr lang="en-US" smtClean="0"/>
               <a:t>Click to edit Master title style</a:t>
             </a:r>
+            <a:endParaRPr lang="en-US"/>
           </a:p>
         </p:txBody>
       </p:sp>
@@ -2505,7 +2500,7 @@
           <a:p>
             <a:pPr lvl="0"/>
             <a:r>
-              <a:rPr lang="en-US"/>
+              <a:rPr lang="en-US" smtClean="0"/>
               <a:t>Click to edit Master text styles</a:t>
             </a:r>
           </a:p>
@@ -2528,7 +2523,7 @@
           <a:p>
             <a:fld id="{5BCAD085-E8A6-8845-BD4E-CB4CCA059FC4}" type="datetimeFigureOut">
               <a:rPr lang="en-US" smtClean="0"/>
-              <a:t>5/25/26</a:t>
+              <a:t>1/27/13</a:t>
             </a:fld>
             <a:endParaRPr lang="en-US"/>
           </a:p>
@@ -2637,9 +2632,10 @@
           <a:lstStyle/>
           <a:p>
             <a:r>
-              <a:rPr lang="en-US"/>
+              <a:rPr lang="en-US" smtClean="0"/>
               <a:t>Click to edit Master title style</a:t>
             </a:r>
+            <a:endParaRPr lang="en-US"/>
           </a:p>
         </p:txBody>
       </p:sp>
@@ -2670,37 +2666,38 @@
           <a:p>
             <a:pPr lvl="0"/>
             <a:r>
-              <a:rPr lang="en-US"/>
+              <a:rPr lang="en-US" smtClean="0"/>
               <a:t>Click to edit Master text styles</a:t>
             </a:r>
           </a:p>
           <a:p>
             <a:pPr lvl="1"/>
             <a:r>
-              <a:rPr lang="en-US"/>
+              <a:rPr lang="en-US" smtClean="0"/>
               <a:t>Second level</a:t>
             </a:r>
           </a:p>
           <a:p>
             <a:pPr lvl="2"/>
             <a:r>
-              <a:rPr lang="en-US"/>
+              <a:rPr lang="en-US" smtClean="0"/>
               <a:t>Third level</a:t>
             </a:r>
           </a:p>
           <a:p>
             <a:pPr lvl="3"/>
             <a:r>
-              <a:rPr lang="en-US"/>
+              <a:rPr lang="en-US" smtClean="0"/>
               <a:t>Fourth level</a:t>
             </a:r>
           </a:p>
           <a:p>
             <a:pPr lvl="4"/>
             <a:r>
-              <a:rPr lang="en-US"/>
+              <a:rPr lang="en-US" smtClean="0"/>
               <a:t>Fifth level</a:t>
             </a:r>
+            <a:endParaRPr lang="en-US"/>
           </a:p>
         </p:txBody>
       </p:sp>
@@ -2739,7 +2736,7 @@
           <a:p>
             <a:fld id="{5BCAD085-E8A6-8845-BD4E-CB4CCA059FC4}" type="datetimeFigureOut">
               <a:rPr lang="en-US" smtClean="0"/>
-              <a:t>5/25/26</a:t>
+              <a:t>1/27/13</a:t>
             </a:fld>
             <a:endParaRPr lang="en-US"/>
           </a:p>
@@ -3098,7 +3095,7 @@
 </file>
 
 <file path=ppt/slides/slide1.xml><?xml version="1.0" encoding="utf-8"?>
-<p:sld xmlns:a="http://schemas.openxmlformats.org/drawingml/2006/main" xmlns:r="http://schemas.openxmlformats.org/officeDocument/2006/relationships" xmlns:p="http://schemas.openxmlformats.org/presentationml/2006/main">
+<p:sld xmlns:a="http://schemas.openxmlformats.org/drawingml/2006/main" xmlns:p="http://schemas.openxmlformats.org/presentationml/2006/main" xmlns:r="http://schemas.openxmlformats.org/officeDocument/2006/relationships">
   <p:cSld>
     <p:bg>
       <p:bgPr>
@@ -3114,26 +3111,19 @@
         <p:cNvGrpSpPr/>
         <p:nvPr/>
       </p:nvGrpSpPr>
-      <p:grpSpPr>
-        <a:xfrm>
-          <a:off x="0" y="0"/>
-          <a:ext cx="0" cy="0"/>
-          <a:chOff x="0" y="0"/>
-          <a:chExt cx="0" cy="0"/>
-        </a:xfrm>
-      </p:grpSpPr>
-      <p:sp>
-        <p:nvSpPr>
-          <p:cNvPr id="3" name="Oval 2"/>
+      <p:grpSpPr/>
+      <p:sp>
+        <p:nvSpPr>
+          <p:cNvPr id="2" name="Rounded Rectangle 1"/>
           <p:cNvSpPr/>
           <p:nvPr/>
         </p:nvSpPr>
         <p:spPr>
           <a:xfrm>
-            <a:off x="5577840" y="1463040"/>
-            <a:ext cx="1097280" cy="1097280"/>
-          </a:xfrm>
-          <a:prstGeom prst="ellipse">
+            <a:off x="0" y="0"/>
+            <a:ext cx="12191695" cy="73152"/>
+          </a:xfrm>
+          <a:prstGeom prst="roundRect">
             <a:avLst/>
           </a:prstGeom>
           <a:solidFill>
@@ -3158,7 +3148,50 @@
           </a:fontRef>
         </p:style>
         <p:txBody>
-          <a:bodyPr wrap="none" rtlCol="0" anchor="ctr"/>
+          <a:bodyPr rtlCol="0" anchor="ctr"/>
+          <a:lstStyle/>
+          <a:p>
+            <a:pPr algn="ctr"/>
+          </a:p>
+        </p:txBody>
+      </p:sp>
+      <p:sp>
+        <p:nvSpPr>
+          <p:cNvPr id="3" name="Oval 2"/>
+          <p:cNvSpPr/>
+          <p:nvPr/>
+        </p:nvSpPr>
+        <p:spPr>
+          <a:xfrm>
+            <a:off x="5577840" y="1463040"/>
+            <a:ext cx="1097280" cy="1097280"/>
+          </a:xfrm>
+          <a:prstGeom prst="ellipse">
+            <a:avLst/>
+          </a:prstGeom>
+          <a:solidFill>
+            <a:srgbClr val="1A73E8"/>
+          </a:solidFill>
+          <a:ln>
+            <a:noFill/>
+          </a:ln>
+        </p:spPr>
+        <p:style>
+          <a:lnRef idx="1">
+            <a:schemeClr val="accent1"/>
+          </a:lnRef>
+          <a:fillRef idx="3">
+            <a:schemeClr val="accent1"/>
+          </a:fillRef>
+          <a:effectRef idx="2">
+            <a:schemeClr val="accent1"/>
+          </a:effectRef>
+          <a:fontRef idx="minor">
+            <a:schemeClr val="lt1"/>
+          </a:fontRef>
+        </p:style>
+        <p:txBody>
+          <a:bodyPr rtlCol="0" anchor="ctr" wrap="none"/>
           <a:lstStyle/>
           <a:p>
             <a:pPr algn="ctr">
@@ -3218,7 +3251,7 @@
         <p:spPr>
           <a:xfrm>
             <a:off x="457200" y="3931920"/>
-            <a:ext cx="11247120" cy="1015663"/>
+            <a:ext cx="11247120" cy="731520"/>
           </a:xfrm>
           <a:prstGeom prst="rect">
             <a:avLst/>
@@ -3245,33 +3278,6 @@
             <a:r>
               <a:t>全仿真 · 完整链路 · 实时看板</a:t>
             </a:r>
-            <a:endParaRPr lang="en-US"/>
-          </a:p>
-          <a:p>
-            <a:pPr algn="ctr">
-              <a:defRPr sz="2000" b="0">
-                <a:solidFill>
-                  <a:srgbClr val="64748B"/>
-                </a:solidFill>
-              </a:defRPr>
-            </a:pPr>
-            <a:r>
-              <a:rPr lang="zh-CN" altLang="en-US"/>
-              <a:t>互联</a:t>
-            </a:r>
-            <a:r>
-              <a:rPr lang="en-US" altLang="zh-CN"/>
-              <a:t>2313</a:t>
-            </a:r>
-            <a:r>
-              <a:rPr lang="zh-CN" altLang="en-US"/>
-              <a:t> 组别</a:t>
-            </a:r>
-            <a:r>
-              <a:rPr lang="en-US" altLang="zh-CN"/>
-              <a:t>2</a:t>
-            </a:r>
-            <a:endParaRPr/>
           </a:p>
         </p:txBody>
       </p:sp>
@@ -3354,7 +3360,7 @@
 </file>
 
 <file path=ppt/slides/slide10.xml><?xml version="1.0" encoding="utf-8"?>
-<p:sld xmlns:a="http://schemas.openxmlformats.org/drawingml/2006/main" xmlns:r="http://schemas.openxmlformats.org/officeDocument/2006/relationships" xmlns:p="http://schemas.openxmlformats.org/presentationml/2006/main">
+<p:sld xmlns:a="http://schemas.openxmlformats.org/drawingml/2006/main" xmlns:p="http://schemas.openxmlformats.org/presentationml/2006/main" xmlns:r="http://schemas.openxmlformats.org/officeDocument/2006/relationships">
   <p:cSld>
     <p:bg>
       <p:bgPr>
@@ -3370,14 +3376,7 @@
         <p:cNvGrpSpPr/>
         <p:nvPr/>
       </p:nvGrpSpPr>
-      <p:grpSpPr>
-        <a:xfrm>
-          <a:off x="0" y="0"/>
-          <a:ext cx="0" cy="0"/>
-          <a:chOff x="0" y="0"/>
-          <a:chExt cx="0" cy="0"/>
-        </a:xfrm>
-      </p:grpSpPr>
+      <p:grpSpPr/>
       <p:sp>
         <p:nvSpPr>
           <p:cNvPr id="2" name="TextBox 1"/>
@@ -3492,7 +3491,7 @@
 </file>
 
 <file path=ppt/slides/slide11.xml><?xml version="1.0" encoding="utf-8"?>
-<p:sld xmlns:a="http://schemas.openxmlformats.org/drawingml/2006/main" xmlns:r="http://schemas.openxmlformats.org/officeDocument/2006/relationships" xmlns:p="http://schemas.openxmlformats.org/presentationml/2006/main">
+<p:sld xmlns:a="http://schemas.openxmlformats.org/drawingml/2006/main" xmlns:p="http://schemas.openxmlformats.org/presentationml/2006/main" xmlns:r="http://schemas.openxmlformats.org/officeDocument/2006/relationships">
   <p:cSld>
     <p:bg>
       <p:bgPr>
@@ -3508,14 +3507,7 @@
         <p:cNvGrpSpPr/>
         <p:nvPr/>
       </p:nvGrpSpPr>
-      <p:grpSpPr>
-        <a:xfrm>
-          <a:off x="0" y="0"/>
-          <a:ext cx="0" cy="0"/>
-          <a:chOff x="0" y="0"/>
-          <a:chExt cx="0" cy="0"/>
-        </a:xfrm>
-      </p:grpSpPr>
+      <p:grpSpPr/>
       <p:sp>
         <p:nvSpPr>
           <p:cNvPr id="2" name="TextBox 1"/>
@@ -3624,7 +3616,7 @@
           </a:fontRef>
         </p:style>
         <p:txBody>
-          <a:bodyPr wrap="square" lIns="182880" tIns="137160" rIns="137160" bIns="91440" rtlCol="0" anchor="ctr"/>
+          <a:bodyPr rtlCol="0" anchor="ctr" wrap="square" lIns="182880" rIns="137160" tIns="137160" bIns="91440"/>
           <a:lstStyle/>
           <a:p>
             <a:pPr algn="ctr">
@@ -3696,7 +3688,7 @@
           </a:fontRef>
         </p:style>
         <p:txBody>
-          <a:bodyPr wrap="square" lIns="182880" tIns="137160" rIns="137160" bIns="91440" rtlCol="0" anchor="ctr"/>
+          <a:bodyPr rtlCol="0" anchor="ctr" wrap="square" lIns="182880" rIns="137160" tIns="137160" bIns="91440"/>
           <a:lstStyle/>
           <a:p>
             <a:pPr algn="ctr">
@@ -3768,7 +3760,7 @@
           </a:fontRef>
         </p:style>
         <p:txBody>
-          <a:bodyPr wrap="square" lIns="182880" tIns="137160" rIns="137160" bIns="91440" rtlCol="0" anchor="ctr"/>
+          <a:bodyPr rtlCol="0" anchor="ctr" wrap="square" lIns="182880" rIns="137160" tIns="137160" bIns="91440"/>
           <a:lstStyle/>
           <a:p>
             <a:pPr algn="ctr">
@@ -3840,7 +3832,7 @@
           </a:fontRef>
         </p:style>
         <p:txBody>
-          <a:bodyPr wrap="square" lIns="182880" tIns="137160" rIns="137160" bIns="91440" rtlCol="0" anchor="ctr"/>
+          <a:bodyPr rtlCol="0" anchor="ctr" wrap="square" lIns="182880" rIns="137160" tIns="137160" bIns="91440"/>
           <a:lstStyle/>
           <a:p>
             <a:pPr algn="ctr">
@@ -3928,27 +3920,9 @@
                 <a:tableStyleId>{5C22544A-7EE6-4342-B048-85BDC9FD1C3A}</a:tableStyleId>
               </a:tblPr>
               <a:tblGrid>
-                <a:gridCol w="1097280">
-                  <a:extLst>
-                    <a:ext uri="{9D8B030D-6E8A-4147-A177-3AD203B41FA5}">
-                      <a16:colId xmlns:a16="http://schemas.microsoft.com/office/drawing/2014/main" val="20000"/>
-                    </a:ext>
-                  </a:extLst>
-                </a:gridCol>
-                <a:gridCol w="1645920">
-                  <a:extLst>
-                    <a:ext uri="{9D8B030D-6E8A-4147-A177-3AD203B41FA5}">
-                      <a16:colId xmlns:a16="http://schemas.microsoft.com/office/drawing/2014/main" val="20001"/>
-                    </a:ext>
-                  </a:extLst>
-                </a:gridCol>
-                <a:gridCol w="1097280">
-                  <a:extLst>
-                    <a:ext uri="{9D8B030D-6E8A-4147-A177-3AD203B41FA5}">
-                      <a16:colId xmlns:a16="http://schemas.microsoft.com/office/drawing/2014/main" val="20002"/>
-                    </a:ext>
-                  </a:extLst>
-                </a:gridCol>
+                <a:gridCol w="1097280"/>
+                <a:gridCol w="1645920"/>
+                <a:gridCol w="1097280"/>
               </a:tblGrid>
               <a:tr h="320040">
                 <a:tc>
@@ -4020,11 +3994,6 @@
                     </a:solidFill>
                   </a:tcPr>
                 </a:tc>
-                <a:extLst>
-                  <a:ext uri="{0D108BD9-81ED-4DB2-BD59-A6C34878D82A}">
-                    <a16:rowId xmlns:a16="http://schemas.microsoft.com/office/drawing/2014/main" val="10000"/>
-                  </a:ext>
-                </a:extLst>
               </a:tr>
               <a:tr h="320040">
                 <a:tc>
@@ -4084,11 +4053,6 @@
                   </a:txBody>
                   <a:tcPr/>
                 </a:tc>
-                <a:extLst>
-                  <a:ext uri="{0D108BD9-81ED-4DB2-BD59-A6C34878D82A}">
-                    <a16:rowId xmlns:a16="http://schemas.microsoft.com/office/drawing/2014/main" val="10001"/>
-                  </a:ext>
-                </a:extLst>
               </a:tr>
               <a:tr h="320040">
                 <a:tc>
@@ -4148,11 +4112,6 @@
                   </a:txBody>
                   <a:tcPr/>
                 </a:tc>
-                <a:extLst>
-                  <a:ext uri="{0D108BD9-81ED-4DB2-BD59-A6C34878D82A}">
-                    <a16:rowId xmlns:a16="http://schemas.microsoft.com/office/drawing/2014/main" val="10002"/>
-                  </a:ext>
-                </a:extLst>
               </a:tr>
               <a:tr h="320040">
                 <a:tc>
@@ -4212,11 +4171,6 @@
                   </a:txBody>
                   <a:tcPr/>
                 </a:tc>
-                <a:extLst>
-                  <a:ext uri="{0D108BD9-81ED-4DB2-BD59-A6C34878D82A}">
-                    <a16:rowId xmlns:a16="http://schemas.microsoft.com/office/drawing/2014/main" val="10003"/>
-                  </a:ext>
-                </a:extLst>
               </a:tr>
               <a:tr h="320040">
                 <a:tc>
@@ -4276,11 +4230,6 @@
                   </a:txBody>
                   <a:tcPr/>
                 </a:tc>
-                <a:extLst>
-                  <a:ext uri="{0D108BD9-81ED-4DB2-BD59-A6C34878D82A}">
-                    <a16:rowId xmlns:a16="http://schemas.microsoft.com/office/drawing/2014/main" val="10004"/>
-                  </a:ext>
-                </a:extLst>
               </a:tr>
             </a:tbl>
           </a:graphicData>
@@ -4324,7 +4273,7 @@
           </a:fontRef>
         </p:style>
         <p:txBody>
-          <a:bodyPr wrap="square" lIns="182880" tIns="137160" rIns="137160" bIns="91440" rtlCol="0" anchor="ctr"/>
+          <a:bodyPr rtlCol="0" anchor="ctr" wrap="square" lIns="182880" rIns="137160" tIns="137160" bIns="91440"/>
           <a:lstStyle/>
           <a:p>
             <a:pPr algn="ctr">
@@ -4492,7 +4441,7 @@
 </file>
 
 <file path=ppt/slides/slide12.xml><?xml version="1.0" encoding="utf-8"?>
-<p:sld xmlns:a="http://schemas.openxmlformats.org/drawingml/2006/main" xmlns:r="http://schemas.openxmlformats.org/officeDocument/2006/relationships" xmlns:p="http://schemas.openxmlformats.org/presentationml/2006/main">
+<p:sld xmlns:a="http://schemas.openxmlformats.org/drawingml/2006/main" xmlns:p="http://schemas.openxmlformats.org/presentationml/2006/main" xmlns:r="http://schemas.openxmlformats.org/officeDocument/2006/relationships">
   <p:cSld>
     <p:bg>
       <p:bgPr>
@@ -4508,14 +4457,7 @@
         <p:cNvGrpSpPr/>
         <p:nvPr/>
       </p:nvGrpSpPr>
-      <p:grpSpPr>
-        <a:xfrm>
-          <a:off x="0" y="0"/>
-          <a:ext cx="0" cy="0"/>
-          <a:chOff x="0" y="0"/>
-          <a:chExt cx="0" cy="0"/>
-        </a:xfrm>
-      </p:grpSpPr>
+      <p:grpSpPr/>
       <p:sp>
         <p:nvSpPr>
           <p:cNvPr id="2" name="TextBox 1"/>
@@ -4630,7 +4572,7 @@
 </file>
 
 <file path=ppt/slides/slide13.xml><?xml version="1.0" encoding="utf-8"?>
-<p:sld xmlns:a="http://schemas.openxmlformats.org/drawingml/2006/main" xmlns:r="http://schemas.openxmlformats.org/officeDocument/2006/relationships" xmlns:p="http://schemas.openxmlformats.org/presentationml/2006/main">
+<p:sld xmlns:a="http://schemas.openxmlformats.org/drawingml/2006/main" xmlns:p="http://schemas.openxmlformats.org/presentationml/2006/main" xmlns:r="http://schemas.openxmlformats.org/officeDocument/2006/relationships">
   <p:cSld>
     <p:bg>
       <p:bgPr>
@@ -4646,14 +4588,7 @@
         <p:cNvGrpSpPr/>
         <p:nvPr/>
       </p:nvGrpSpPr>
-      <p:grpSpPr>
-        <a:xfrm>
-          <a:off x="0" y="0"/>
-          <a:ext cx="0" cy="0"/>
-          <a:chOff x="0" y="0"/>
-          <a:chExt cx="0" cy="0"/>
-        </a:xfrm>
-      </p:grpSpPr>
+      <p:grpSpPr/>
       <p:sp>
         <p:nvSpPr>
           <p:cNvPr id="2" name="TextBox 1"/>
@@ -4766,7 +4701,6 @@
           <a:lstStyle/>
           <a:p>
             <a:pPr algn="ctr"/>
-            <a:endParaRPr/>
           </a:p>
         </p:txBody>
       </p:sp>
@@ -4810,7 +4744,6 @@
           <a:lstStyle/>
           <a:p>
             <a:pPr algn="ctr"/>
-            <a:endParaRPr/>
           </a:p>
         </p:txBody>
       </p:sp>
@@ -4926,7 +4859,6 @@
           <a:lstStyle/>
           <a:p>
             <a:pPr algn="ctr"/>
-            <a:endParaRPr/>
           </a:p>
         </p:txBody>
       </p:sp>
@@ -4970,7 +4902,6 @@
           <a:lstStyle/>
           <a:p>
             <a:pPr algn="ctr"/>
-            <a:endParaRPr/>
           </a:p>
         </p:txBody>
       </p:sp>
@@ -5086,7 +5017,6 @@
           <a:lstStyle/>
           <a:p>
             <a:pPr algn="ctr"/>
-            <a:endParaRPr/>
           </a:p>
         </p:txBody>
       </p:sp>
@@ -5130,7 +5060,6 @@
           <a:lstStyle/>
           <a:p>
             <a:pPr algn="ctr"/>
-            <a:endParaRPr/>
           </a:p>
         </p:txBody>
       </p:sp>
@@ -5246,7 +5175,6 @@
           <a:lstStyle/>
           <a:p>
             <a:pPr algn="ctr"/>
-            <a:endParaRPr/>
           </a:p>
         </p:txBody>
       </p:sp>
@@ -5290,7 +5218,6 @@
           <a:lstStyle/>
           <a:p>
             <a:pPr algn="ctr"/>
-            <a:endParaRPr/>
           </a:p>
         </p:txBody>
       </p:sp>
@@ -5406,7 +5333,6 @@
           <a:lstStyle/>
           <a:p>
             <a:pPr algn="ctr"/>
-            <a:endParaRPr/>
           </a:p>
         </p:txBody>
       </p:sp>
@@ -5450,7 +5376,6 @@
           <a:lstStyle/>
           <a:p>
             <a:pPr algn="ctr"/>
-            <a:endParaRPr/>
           </a:p>
         </p:txBody>
       </p:sp>
@@ -5566,7 +5491,6 @@
           <a:lstStyle/>
           <a:p>
             <a:pPr algn="ctr"/>
-            <a:endParaRPr/>
           </a:p>
         </p:txBody>
       </p:sp>
@@ -5610,7 +5534,6 @@
           <a:lstStyle/>
           <a:p>
             <a:pPr algn="ctr"/>
-            <a:endParaRPr/>
           </a:p>
         </p:txBody>
       </p:sp>
@@ -5724,7 +5647,6 @@
           <a:lstStyle/>
           <a:p>
             <a:pPr algn="ctr"/>
-            <a:endParaRPr/>
           </a:p>
         </p:txBody>
       </p:sp>
@@ -5772,7 +5694,7 @@
 </file>
 
 <file path=ppt/slides/slide14.xml><?xml version="1.0" encoding="utf-8"?>
-<p:sld xmlns:a="http://schemas.openxmlformats.org/drawingml/2006/main" xmlns:r="http://schemas.openxmlformats.org/officeDocument/2006/relationships" xmlns:p="http://schemas.openxmlformats.org/presentationml/2006/main">
+<p:sld xmlns:a="http://schemas.openxmlformats.org/drawingml/2006/main" xmlns:p="http://schemas.openxmlformats.org/presentationml/2006/main" xmlns:r="http://schemas.openxmlformats.org/officeDocument/2006/relationships">
   <p:cSld>
     <p:bg>
       <p:bgPr>
@@ -5788,14 +5710,7 @@
         <p:cNvGrpSpPr/>
         <p:nvPr/>
       </p:nvGrpSpPr>
-      <p:grpSpPr>
-        <a:xfrm>
-          <a:off x="0" y="0"/>
-          <a:ext cx="0" cy="0"/>
-          <a:chOff x="0" y="0"/>
-          <a:chExt cx="0" cy="0"/>
-        </a:xfrm>
-      </p:grpSpPr>
+      <p:grpSpPr/>
       <p:sp>
         <p:nvSpPr>
           <p:cNvPr id="2" name="TextBox 1"/>
@@ -5910,7 +5825,7 @@
 </file>
 
 <file path=ppt/slides/slide15.xml><?xml version="1.0" encoding="utf-8"?>
-<p:sld xmlns:a="http://schemas.openxmlformats.org/drawingml/2006/main" xmlns:r="http://schemas.openxmlformats.org/officeDocument/2006/relationships" xmlns:p="http://schemas.openxmlformats.org/presentationml/2006/main">
+<p:sld xmlns:a="http://schemas.openxmlformats.org/drawingml/2006/main" xmlns:p="http://schemas.openxmlformats.org/presentationml/2006/main" xmlns:r="http://schemas.openxmlformats.org/officeDocument/2006/relationships">
   <p:cSld>
     <p:bg>
       <p:bgPr>
@@ -5926,14 +5841,7 @@
         <p:cNvGrpSpPr/>
         <p:nvPr/>
       </p:nvGrpSpPr>
-      <p:grpSpPr>
-        <a:xfrm>
-          <a:off x="0" y="0"/>
-          <a:ext cx="0" cy="0"/>
-          <a:chOff x="0" y="0"/>
-          <a:chExt cx="0" cy="0"/>
-        </a:xfrm>
-      </p:grpSpPr>
+      <p:grpSpPr/>
       <p:sp>
         <p:nvSpPr>
           <p:cNvPr id="2" name="TextBox 1"/>
@@ -6013,7 +5921,7 @@
         <p:spPr>
           <a:xfrm>
             <a:off x="731520" y="1280160"/>
-            <a:ext cx="5303520" cy="1327116"/>
+            <a:ext cx="5303520" cy="640080"/>
           </a:xfrm>
           <a:prstGeom prst="roundRect">
             <a:avLst/>
@@ -6040,7 +5948,7 @@
           </a:fontRef>
         </p:style>
         <p:txBody>
-          <a:bodyPr wrap="square" lIns="182880" tIns="109728" bIns="109728" rtlCol="0" anchor="ctr"/>
+          <a:bodyPr rtlCol="0" anchor="ctr" wrap="square" lIns="182880" tIns="109728" bIns="109728"/>
           <a:lstStyle/>
           <a:p>
             <a:pPr algn="ctr">
@@ -6112,7 +6020,7 @@
           </a:fontRef>
         </p:style>
         <p:txBody>
-          <a:bodyPr wrap="square" lIns="182880" tIns="109728" bIns="109728" rtlCol="0" anchor="ctr"/>
+          <a:bodyPr rtlCol="0" anchor="ctr" wrap="square" lIns="182880" tIns="109728" bIns="109728"/>
           <a:lstStyle/>
           <a:p>
             <a:pPr algn="ctr">
@@ -6202,7 +6110,7 @@
           </a:fontRef>
         </p:style>
         <p:txBody>
-          <a:bodyPr wrap="square" lIns="182880" tIns="137160" rIns="137160" bIns="91440" rtlCol="0" anchor="ctr"/>
+          <a:bodyPr rtlCol="0" anchor="ctr" wrap="square" lIns="182880" rIns="137160" tIns="137160" bIns="91440"/>
           <a:lstStyle/>
           <a:p>
             <a:pPr algn="ctr">
@@ -6350,7 +6258,7 @@
         <p:spPr>
           <a:xfrm>
             <a:off x="6400800" y="3474720"/>
-            <a:ext cx="5303520" cy="2011680"/>
+            <a:ext cx="5303520" cy="1645920"/>
           </a:xfrm>
           <a:prstGeom prst="roundRect">
             <a:avLst/>
@@ -6379,7 +6287,7 @@
           </a:fontRef>
         </p:style>
         <p:txBody>
-          <a:bodyPr wrap="square" lIns="182880" tIns="137160" rIns="137160" bIns="91440" rtlCol="0" anchor="ctr"/>
+          <a:bodyPr rtlCol="0" anchor="ctr" wrap="square" lIns="182880" rIns="137160" tIns="137160" bIns="91440"/>
           <a:lstStyle/>
           <a:p>
             <a:pPr algn="ctr">
@@ -6437,7 +6345,6 @@
                 </a:solidFill>
               </a:defRPr>
             </a:pPr>
-            <a:endParaRPr/>
           </a:p>
           <a:p>
             <a:pPr>
@@ -6480,7 +6387,6 @@
                 </a:solidFill>
               </a:defRPr>
             </a:pPr>
-            <a:endParaRPr/>
           </a:p>
           <a:p>
             <a:pPr>
@@ -6573,7 +6479,7 @@
 </file>
 
 <file path=ppt/slides/slide16.xml><?xml version="1.0" encoding="utf-8"?>
-<p:sld xmlns:a="http://schemas.openxmlformats.org/drawingml/2006/main" xmlns:r="http://schemas.openxmlformats.org/officeDocument/2006/relationships" xmlns:p="http://schemas.openxmlformats.org/presentationml/2006/main">
+<p:sld xmlns:a="http://schemas.openxmlformats.org/drawingml/2006/main" xmlns:p="http://schemas.openxmlformats.org/presentationml/2006/main" xmlns:r="http://schemas.openxmlformats.org/officeDocument/2006/relationships">
   <p:cSld>
     <p:bg>
       <p:bgPr>
@@ -6589,14 +6495,7 @@
         <p:cNvGrpSpPr/>
         <p:nvPr/>
       </p:nvGrpSpPr>
-      <p:grpSpPr>
-        <a:xfrm>
-          <a:off x="0" y="0"/>
-          <a:ext cx="0" cy="0"/>
-          <a:chOff x="0" y="0"/>
-          <a:chExt cx="0" cy="0"/>
-        </a:xfrm>
-      </p:grpSpPr>
+      <p:grpSpPr/>
       <p:sp>
         <p:nvSpPr>
           <p:cNvPr id="2" name="TextBox 1"/>
@@ -6676,7 +6575,7 @@
         <p:spPr>
           <a:xfrm>
             <a:off x="731520" y="1280160"/>
-            <a:ext cx="2980450" cy="1691641"/>
+            <a:ext cx="3566160" cy="2011680"/>
           </a:xfrm>
           <a:prstGeom prst="roundRect">
             <a:avLst/>
@@ -6705,7 +6604,7 @@
           </a:fontRef>
         </p:style>
         <p:txBody>
-          <a:bodyPr wrap="square" lIns="182880" tIns="137160" rIns="137160" bIns="91440" rtlCol="0" anchor="ctr"/>
+          <a:bodyPr rtlCol="0" anchor="ctr" wrap="square" lIns="182880" rIns="137160" tIns="137160" bIns="91440"/>
           <a:lstStyle/>
           <a:p>
             <a:pPr algn="ctr">
@@ -6793,7 +6692,7 @@
         <p:spPr>
           <a:xfrm>
             <a:off x="4572000" y="1280160"/>
-            <a:ext cx="2980450" cy="1691641"/>
+            <a:ext cx="3566160" cy="2011680"/>
           </a:xfrm>
           <a:prstGeom prst="roundRect">
             <a:avLst/>
@@ -6822,7 +6721,7 @@
           </a:fontRef>
         </p:style>
         <p:txBody>
-          <a:bodyPr wrap="square" lIns="182880" tIns="137160" rIns="137160" bIns="91440" rtlCol="0" anchor="ctr"/>
+          <a:bodyPr rtlCol="0" anchor="ctr" wrap="square" lIns="182880" rIns="137160" tIns="137160" bIns="91440"/>
           <a:lstStyle/>
           <a:p>
             <a:pPr algn="ctr">
@@ -6910,7 +6809,7 @@
         <p:spPr>
           <a:xfrm>
             <a:off x="8412480" y="1280160"/>
-            <a:ext cx="2980450" cy="1691641"/>
+            <a:ext cx="3566160" cy="2011680"/>
           </a:xfrm>
           <a:prstGeom prst="roundRect">
             <a:avLst/>
@@ -6939,7 +6838,7 @@
           </a:fontRef>
         </p:style>
         <p:txBody>
-          <a:bodyPr wrap="square" lIns="182880" tIns="137160" rIns="137160" bIns="91440" rtlCol="0" anchor="ctr"/>
+          <a:bodyPr rtlCol="0" anchor="ctr" wrap="square" lIns="182880" rIns="137160" tIns="137160" bIns="91440"/>
           <a:lstStyle/>
           <a:p>
             <a:pPr algn="ctr">
@@ -7026,8 +6925,8 @@
         </p:nvSpPr>
         <p:spPr>
           <a:xfrm>
-            <a:off x="795775" y="2971801"/>
-            <a:ext cx="3477545" cy="307777"/>
+            <a:off x="731520" y="3566160"/>
+            <a:ext cx="4572000" cy="274320"/>
           </a:xfrm>
           <a:prstGeom prst="rect">
             <a:avLst/>
@@ -7061,8 +6960,8 @@
         </p:nvSpPr>
         <p:spPr>
           <a:xfrm>
-            <a:off x="795775" y="3337561"/>
-            <a:ext cx="1947425" cy="714221"/>
+            <a:off x="731520" y="3931920"/>
+            <a:ext cx="2560320" cy="1097280"/>
           </a:xfrm>
           <a:prstGeom prst="roundRect">
             <a:avLst/>
@@ -7091,7 +6990,7 @@
           </a:fontRef>
         </p:style>
         <p:txBody>
-          <a:bodyPr wrap="square" rtlCol="0" anchor="ctr"/>
+          <a:bodyPr rtlCol="0" anchor="ctr" wrap="square"/>
           <a:lstStyle/>
           <a:p>
             <a:pPr algn="ctr">
@@ -7127,8 +7026,8 @@
         </p:nvSpPr>
         <p:spPr>
           <a:xfrm>
-            <a:off x="3630415" y="3337561"/>
-            <a:ext cx="1947425" cy="714221"/>
+            <a:off x="3566160" y="3931920"/>
+            <a:ext cx="2560320" cy="1097280"/>
           </a:xfrm>
           <a:prstGeom prst="roundRect">
             <a:avLst/>
@@ -7157,7 +7056,7 @@
           </a:fontRef>
         </p:style>
         <p:txBody>
-          <a:bodyPr wrap="square" rtlCol="0" anchor="ctr"/>
+          <a:bodyPr rtlCol="0" anchor="ctr" wrap="square"/>
           <a:lstStyle/>
           <a:p>
             <a:pPr algn="ctr">
@@ -7193,8 +7092,8 @@
         </p:nvSpPr>
         <p:spPr>
           <a:xfrm>
-            <a:off x="6465055" y="3337561"/>
-            <a:ext cx="1947425" cy="714221"/>
+            <a:off x="6400800" y="3931920"/>
+            <a:ext cx="2560320" cy="1097280"/>
           </a:xfrm>
           <a:prstGeom prst="roundRect">
             <a:avLst/>
@@ -7223,7 +7122,7 @@
           </a:fontRef>
         </p:style>
         <p:txBody>
-          <a:bodyPr wrap="square" rtlCol="0" anchor="ctr"/>
+          <a:bodyPr rtlCol="0" anchor="ctr" wrap="square"/>
           <a:lstStyle/>
           <a:p>
             <a:pPr algn="ctr">
@@ -7259,8 +7158,8 @@
         </p:nvSpPr>
         <p:spPr>
           <a:xfrm>
-            <a:off x="9299695" y="3337561"/>
-            <a:ext cx="1947425" cy="714221"/>
+            <a:off x="9235440" y="3931920"/>
+            <a:ext cx="2560320" cy="1097280"/>
           </a:xfrm>
           <a:prstGeom prst="roundRect">
             <a:avLst/>
@@ -7289,7 +7188,7 @@
           </a:fontRef>
         </p:style>
         <p:txBody>
-          <a:bodyPr wrap="square" rtlCol="0" anchor="ctr"/>
+          <a:bodyPr rtlCol="0" anchor="ctr" wrap="square"/>
           <a:lstStyle/>
           <a:p>
             <a:pPr algn="ctr">
@@ -7325,7 +7224,7 @@
         </p:nvSpPr>
         <p:spPr>
           <a:xfrm>
-            <a:off x="763648" y="4165557"/>
+            <a:off x="731520" y="5303520"/>
             <a:ext cx="4572000" cy="274320"/>
           </a:xfrm>
           <a:prstGeom prst="rect">
@@ -7358,16 +7257,10 @@
           <p:cNvGraphicFramePr>
             <a:graphicFrameLocks noGrp="1"/>
           </p:cNvGraphicFramePr>
-          <p:nvPr>
-            <p:extLst>
-              <p:ext uri="{D42A27DB-BD31-4B8C-83A1-F6EECF244321}">
-                <p14:modId xmlns:p14="http://schemas.microsoft.com/office/powerpoint/2010/main" val="3533528023"/>
-              </p:ext>
-            </p:extLst>
-          </p:nvPr>
+          <p:nvPr/>
         </p:nvGraphicFramePr>
         <p:xfrm>
-          <a:off x="641728" y="4463262"/>
+          <a:off x="731520" y="5577840"/>
           <a:ext cx="10972800" cy="1920239"/>
         </p:xfrm>
         <a:graphic>
@@ -7377,34 +7270,10 @@
                 <a:tableStyleId>{5C22544A-7EE6-4342-B048-85BDC9FD1C3A}</a:tableStyleId>
               </a:tblPr>
               <a:tblGrid>
-                <a:gridCol w="2743200">
-                  <a:extLst>
-                    <a:ext uri="{9D8B030D-6E8A-4147-A177-3AD203B41FA5}">
-                      <a16:colId xmlns:a16="http://schemas.microsoft.com/office/drawing/2014/main" val="20000"/>
-                    </a:ext>
-                  </a:extLst>
-                </a:gridCol>
-                <a:gridCol w="2743200">
-                  <a:extLst>
-                    <a:ext uri="{9D8B030D-6E8A-4147-A177-3AD203B41FA5}">
-                      <a16:colId xmlns:a16="http://schemas.microsoft.com/office/drawing/2014/main" val="20001"/>
-                    </a:ext>
-                  </a:extLst>
-                </a:gridCol>
-                <a:gridCol w="2743200">
-                  <a:extLst>
-                    <a:ext uri="{9D8B030D-6E8A-4147-A177-3AD203B41FA5}">
-                      <a16:colId xmlns:a16="http://schemas.microsoft.com/office/drawing/2014/main" val="20002"/>
-                    </a:ext>
-                  </a:extLst>
-                </a:gridCol>
-                <a:gridCol w="2743200">
-                  <a:extLst>
-                    <a:ext uri="{9D8B030D-6E8A-4147-A177-3AD203B41FA5}">
-                      <a16:colId xmlns:a16="http://schemas.microsoft.com/office/drawing/2014/main" val="20003"/>
-                    </a:ext>
-                  </a:extLst>
-                </a:gridCol>
+                <a:gridCol w="2743200"/>
+                <a:gridCol w="2743200"/>
+                <a:gridCol w="2743200"/>
+                <a:gridCol w="2743200"/>
               </a:tblGrid>
               <a:tr h="320039">
                 <a:tc>
@@ -7499,11 +7368,6 @@
                     </a:solidFill>
                   </a:tcPr>
                 </a:tc>
-                <a:extLst>
-                  <a:ext uri="{0D108BD9-81ED-4DB2-BD59-A6C34878D82A}">
-                    <a16:rowId xmlns:a16="http://schemas.microsoft.com/office/drawing/2014/main" val="10000"/>
-                  </a:ext>
-                </a:extLst>
               </a:tr>
               <a:tr h="320039">
                 <a:tc>
@@ -7582,11 +7446,6 @@
                   </a:txBody>
                   <a:tcPr/>
                 </a:tc>
-                <a:extLst>
-                  <a:ext uri="{0D108BD9-81ED-4DB2-BD59-A6C34878D82A}">
-                    <a16:rowId xmlns:a16="http://schemas.microsoft.com/office/drawing/2014/main" val="10001"/>
-                  </a:ext>
-                </a:extLst>
               </a:tr>
               <a:tr h="320039">
                 <a:tc>
@@ -7665,11 +7524,6 @@
                   </a:txBody>
                   <a:tcPr/>
                 </a:tc>
-                <a:extLst>
-                  <a:ext uri="{0D108BD9-81ED-4DB2-BD59-A6C34878D82A}">
-                    <a16:rowId xmlns:a16="http://schemas.microsoft.com/office/drawing/2014/main" val="10002"/>
-                  </a:ext>
-                </a:extLst>
               </a:tr>
               <a:tr h="320039">
                 <a:tc>
@@ -7748,11 +7602,6 @@
                   </a:txBody>
                   <a:tcPr/>
                 </a:tc>
-                <a:extLst>
-                  <a:ext uri="{0D108BD9-81ED-4DB2-BD59-A6C34878D82A}">
-                    <a16:rowId xmlns:a16="http://schemas.microsoft.com/office/drawing/2014/main" val="10003"/>
-                  </a:ext>
-                </a:extLst>
               </a:tr>
               <a:tr h="320039">
                 <a:tc>
@@ -7805,7 +7654,6 @@
                           </a:solidFill>
                         </a:defRPr>
                       </a:pPr>
-                      <a:endParaRPr/>
                     </a:p>
                   </a:txBody>
                   <a:tcPr/>
@@ -7822,16 +7670,10 @@
                           </a:solidFill>
                         </a:defRPr>
                       </a:pPr>
-                      <a:endParaRPr/>
                     </a:p>
                   </a:txBody>
                   <a:tcPr/>
                 </a:tc>
-                <a:extLst>
-                  <a:ext uri="{0D108BD9-81ED-4DB2-BD59-A6C34878D82A}">
-                    <a16:rowId xmlns:a16="http://schemas.microsoft.com/office/drawing/2014/main" val="10004"/>
-                  </a:ext>
-                </a:extLst>
               </a:tr>
               <a:tr h="320044">
                 <a:tc>
@@ -7884,7 +7726,6 @@
                           </a:solidFill>
                         </a:defRPr>
                       </a:pPr>
-                      <a:endParaRPr/>
                     </a:p>
                   </a:txBody>
                   <a:tcPr/>
@@ -7901,16 +7742,10 @@
                           </a:solidFill>
                         </a:defRPr>
                       </a:pPr>
-                      <a:endParaRPr/>
                     </a:p>
                   </a:txBody>
                   <a:tcPr/>
                 </a:tc>
-                <a:extLst>
-                  <a:ext uri="{0D108BD9-81ED-4DB2-BD59-A6C34878D82A}">
-                    <a16:rowId xmlns:a16="http://schemas.microsoft.com/office/drawing/2014/main" val="10005"/>
-                  </a:ext>
-                </a:extLst>
               </a:tr>
             </a:tbl>
           </a:graphicData>
@@ -7924,7 +7759,7 @@
         </p:nvSpPr>
         <p:spPr>
           <a:xfrm>
-            <a:off x="10561320" y="6492240"/>
+            <a:off x="10515600" y="6492240"/>
             <a:ext cx="1371600" cy="274320"/>
           </a:xfrm>
           <a:prstGeom prst="rect">
@@ -7960,7 +7795,7 @@
 </file>
 
 <file path=ppt/slides/slide17.xml><?xml version="1.0" encoding="utf-8"?>
-<p:sld xmlns:a="http://schemas.openxmlformats.org/drawingml/2006/main" xmlns:r="http://schemas.openxmlformats.org/officeDocument/2006/relationships" xmlns:p="http://schemas.openxmlformats.org/presentationml/2006/main">
+<p:sld xmlns:a="http://schemas.openxmlformats.org/drawingml/2006/main" xmlns:p="http://schemas.openxmlformats.org/presentationml/2006/main" xmlns:r="http://schemas.openxmlformats.org/officeDocument/2006/relationships">
   <p:cSld>
     <p:bg>
       <p:bgPr>
@@ -7976,14 +7811,50 @@
         <p:cNvGrpSpPr/>
         <p:nvPr/>
       </p:nvGrpSpPr>
-      <p:grpSpPr>
-        <a:xfrm>
-          <a:off x="0" y="0"/>
-          <a:ext cx="0" cy="0"/>
-          <a:chOff x="0" y="0"/>
-          <a:chExt cx="0" cy="0"/>
-        </a:xfrm>
-      </p:grpSpPr>
+      <p:grpSpPr/>
+      <p:sp>
+        <p:nvSpPr>
+          <p:cNvPr id="2" name="Rounded Rectangle 1"/>
+          <p:cNvSpPr/>
+          <p:nvPr/>
+        </p:nvSpPr>
+        <p:spPr>
+          <a:xfrm>
+            <a:off x="0" y="0"/>
+            <a:ext cx="12191695" cy="73152"/>
+          </a:xfrm>
+          <a:prstGeom prst="roundRect">
+            <a:avLst/>
+          </a:prstGeom>
+          <a:solidFill>
+            <a:srgbClr val="1A73E8"/>
+          </a:solidFill>
+          <a:ln>
+            <a:noFill/>
+          </a:ln>
+        </p:spPr>
+        <p:style>
+          <a:lnRef idx="1">
+            <a:schemeClr val="accent1"/>
+          </a:lnRef>
+          <a:fillRef idx="3">
+            <a:schemeClr val="accent1"/>
+          </a:fillRef>
+          <a:effectRef idx="2">
+            <a:schemeClr val="accent1"/>
+          </a:effectRef>
+          <a:fontRef idx="minor">
+            <a:schemeClr val="lt1"/>
+          </a:fontRef>
+        </p:style>
+        <p:txBody>
+          <a:bodyPr rtlCol="0" anchor="ctr"/>
+          <a:lstStyle/>
+          <a:p>
+            <a:pPr algn="ctr"/>
+          </a:p>
+        </p:txBody>
+      </p:sp>
       <p:sp>
         <p:nvSpPr>
           <p:cNvPr id="3" name="Oval 2"/>
@@ -8108,6 +7979,41 @@
             <a:br/>
             <a:r>
               <a:t>从仿真到实时看板的完整链路</a:t>
+            </a:r>
+          </a:p>
+        </p:txBody>
+      </p:sp>
+      <p:sp>
+        <p:nvSpPr>
+          <p:cNvPr id="6" name="TextBox 5"/>
+          <p:cNvSpPr txBox="1"/>
+          <p:nvPr/>
+        </p:nvSpPr>
+        <p:spPr>
+          <a:xfrm>
+            <a:off x="457200" y="5303520"/>
+            <a:ext cx="11247120" cy="457200"/>
+          </a:xfrm>
+          <a:prstGeom prst="rect">
+            <a:avLst/>
+          </a:prstGeom>
+          <a:noFill/>
+        </p:spPr>
+        <p:txBody>
+          <a:bodyPr wrap="square">
+            <a:spAutoFit/>
+          </a:bodyPr>
+          <a:lstStyle/>
+          <a:p>
+            <a:pPr algn="ctr">
+              <a:defRPr sz="1300" b="0">
+                <a:solidFill>
+                  <a:srgbClr val="64748B"/>
+                </a:solidFill>
+              </a:defRPr>
+            </a:pPr>
+            <a:r>
+              <a:t>详细文档: doc/ARCHITECTURE.md  |  一键启动: bash start.sh</a:t>
             </a:r>
           </a:p>
         </p:txBody>
@@ -8156,7 +8062,7 @@
 </file>
 
 <file path=ppt/slides/slide2.xml><?xml version="1.0" encoding="utf-8"?>
-<p:sld xmlns:a="http://schemas.openxmlformats.org/drawingml/2006/main" xmlns:r="http://schemas.openxmlformats.org/officeDocument/2006/relationships" xmlns:p="http://schemas.openxmlformats.org/presentationml/2006/main">
+<p:sld xmlns:a="http://schemas.openxmlformats.org/drawingml/2006/main" xmlns:p="http://schemas.openxmlformats.org/presentationml/2006/main" xmlns:r="http://schemas.openxmlformats.org/officeDocument/2006/relationships">
   <p:cSld>
     <p:bg>
       <p:bgPr>
@@ -8172,14 +8078,7 @@
         <p:cNvGrpSpPr/>
         <p:nvPr/>
       </p:nvGrpSpPr>
-      <p:grpSpPr>
-        <a:xfrm>
-          <a:off x="0" y="0"/>
-          <a:ext cx="0" cy="0"/>
-          <a:chOff x="0" y="0"/>
-          <a:chExt cx="0" cy="0"/>
-        </a:xfrm>
-      </p:grpSpPr>
+      <p:grpSpPr/>
       <p:sp>
         <p:nvSpPr>
           <p:cNvPr id="2" name="TextBox 1"/>
@@ -8298,7 +8197,7 @@
 </file>
 
 <file path=ppt/slides/slide3.xml><?xml version="1.0" encoding="utf-8"?>
-<p:sld xmlns:a="http://schemas.openxmlformats.org/drawingml/2006/main" xmlns:r="http://schemas.openxmlformats.org/officeDocument/2006/relationships" xmlns:p="http://schemas.openxmlformats.org/presentationml/2006/main">
+<p:sld xmlns:a="http://schemas.openxmlformats.org/drawingml/2006/main" xmlns:p="http://schemas.openxmlformats.org/presentationml/2006/main" xmlns:r="http://schemas.openxmlformats.org/officeDocument/2006/relationships">
   <p:cSld>
     <p:bg>
       <p:bgPr>
@@ -8314,14 +8213,7 @@
         <p:cNvGrpSpPr/>
         <p:nvPr/>
       </p:nvGrpSpPr>
-      <p:grpSpPr>
-        <a:xfrm>
-          <a:off x="0" y="0"/>
-          <a:ext cx="0" cy="0"/>
-          <a:chOff x="0" y="0"/>
-          <a:chExt cx="0" cy="0"/>
-        </a:xfrm>
-      </p:grpSpPr>
+      <p:grpSpPr/>
       <p:sp>
         <p:nvSpPr>
           <p:cNvPr id="2" name="TextBox 1"/>
@@ -8430,7 +8322,7 @@
           </a:fontRef>
         </p:style>
         <p:txBody>
-          <a:bodyPr wrap="square" lIns="182880" tIns="137160" rIns="137160" bIns="91440" rtlCol="0" anchor="ctr"/>
+          <a:bodyPr rtlCol="0" anchor="ctr" wrap="square" lIns="182880" rIns="137160" tIns="137160" bIns="91440"/>
           <a:lstStyle/>
           <a:p>
             <a:pPr algn="ctr">
@@ -8547,7 +8439,7 @@
           </a:fontRef>
         </p:style>
         <p:txBody>
-          <a:bodyPr wrap="square" lIns="182880" tIns="137160" rIns="137160" bIns="91440" rtlCol="0" anchor="ctr"/>
+          <a:bodyPr rtlCol="0" anchor="ctr" wrap="square" lIns="182880" rIns="137160" tIns="137160" bIns="91440"/>
           <a:lstStyle/>
           <a:p>
             <a:pPr algn="ctr">
@@ -8664,7 +8556,7 @@
           </a:fontRef>
         </p:style>
         <p:txBody>
-          <a:bodyPr wrap="square" lIns="182880" tIns="137160" rIns="137160" bIns="91440" rtlCol="0" anchor="ctr"/>
+          <a:bodyPr rtlCol="0" anchor="ctr" wrap="square" lIns="182880" rIns="137160" tIns="137160" bIns="91440"/>
           <a:lstStyle/>
           <a:p>
             <a:pPr algn="ctr">
@@ -8781,7 +8673,7 @@
           </a:fontRef>
         </p:style>
         <p:txBody>
-          <a:bodyPr wrap="square" lIns="182880" tIns="137160" rIns="137160" bIns="91440" rtlCol="0" anchor="ctr"/>
+          <a:bodyPr rtlCol="0" anchor="ctr" wrap="square" lIns="182880" rIns="137160" tIns="137160" bIns="91440"/>
           <a:lstStyle/>
           <a:p>
             <a:pPr algn="ctr">
@@ -8898,7 +8790,7 @@
           </a:fontRef>
         </p:style>
         <p:txBody>
-          <a:bodyPr wrap="square" rtlCol="0" anchor="ctr"/>
+          <a:bodyPr rtlCol="0" anchor="ctr" wrap="square"/>
           <a:lstStyle/>
           <a:p>
             <a:pPr algn="ctr">
@@ -8958,7 +8850,7 @@
           </a:fontRef>
         </p:style>
         <p:txBody>
-          <a:bodyPr wrap="square" rtlCol="0" anchor="ctr"/>
+          <a:bodyPr rtlCol="0" anchor="ctr" wrap="square"/>
           <a:lstStyle/>
           <a:p>
             <a:pPr algn="ctr">
@@ -9018,7 +8910,7 @@
           </a:fontRef>
         </p:style>
         <p:txBody>
-          <a:bodyPr wrap="square" rtlCol="0" anchor="ctr"/>
+          <a:bodyPr rtlCol="0" anchor="ctr" wrap="square"/>
           <a:lstStyle/>
           <a:p>
             <a:pPr algn="ctr">
@@ -9084,7 +8976,7 @@
 </file>
 
 <file path=ppt/slides/slide4.xml><?xml version="1.0" encoding="utf-8"?>
-<p:sld xmlns:a="http://schemas.openxmlformats.org/drawingml/2006/main" xmlns:r="http://schemas.openxmlformats.org/officeDocument/2006/relationships" xmlns:p="http://schemas.openxmlformats.org/presentationml/2006/main">
+<p:sld xmlns:a="http://schemas.openxmlformats.org/drawingml/2006/main" xmlns:p="http://schemas.openxmlformats.org/presentationml/2006/main" xmlns:r="http://schemas.openxmlformats.org/officeDocument/2006/relationships">
   <p:cSld>
     <p:bg>
       <p:bgPr>
@@ -9100,14 +8992,7 @@
         <p:cNvGrpSpPr/>
         <p:nvPr/>
       </p:nvGrpSpPr>
-      <p:grpSpPr>
-        <a:xfrm>
-          <a:off x="0" y="0"/>
-          <a:ext cx="0" cy="0"/>
-          <a:chOff x="0" y="0"/>
-          <a:chExt cx="0" cy="0"/>
-        </a:xfrm>
-      </p:grpSpPr>
+      <p:grpSpPr/>
       <p:sp>
         <p:nvSpPr>
           <p:cNvPr id="2" name="TextBox 1"/>
@@ -9222,7 +9107,7 @@
 </file>
 
 <file path=ppt/slides/slide5.xml><?xml version="1.0" encoding="utf-8"?>
-<p:sld xmlns:a="http://schemas.openxmlformats.org/drawingml/2006/main" xmlns:r="http://schemas.openxmlformats.org/officeDocument/2006/relationships" xmlns:p="http://schemas.openxmlformats.org/presentationml/2006/main">
+<p:sld xmlns:a="http://schemas.openxmlformats.org/drawingml/2006/main" xmlns:p="http://schemas.openxmlformats.org/presentationml/2006/main" xmlns:r="http://schemas.openxmlformats.org/officeDocument/2006/relationships">
   <p:cSld>
     <p:bg>
       <p:bgPr>
@@ -9238,14 +9123,7 @@
         <p:cNvGrpSpPr/>
         <p:nvPr/>
       </p:nvGrpSpPr>
-      <p:grpSpPr>
-        <a:xfrm>
-          <a:off x="0" y="0"/>
-          <a:ext cx="0" cy="0"/>
-          <a:chOff x="0" y="0"/>
-          <a:chExt cx="0" cy="0"/>
-        </a:xfrm>
-      </p:grpSpPr>
+      <p:grpSpPr/>
       <p:sp>
         <p:nvSpPr>
           <p:cNvPr id="2" name="TextBox 1"/>
@@ -9354,7 +9232,7 @@
           </a:fontRef>
         </p:style>
         <p:txBody>
-          <a:bodyPr wrap="square" rtlCol="0" anchor="ctr"/>
+          <a:bodyPr rtlCol="0" anchor="ctr" wrap="square"/>
           <a:lstStyle/>
           <a:p>
             <a:pPr algn="ctr">
@@ -9453,7 +9331,6 @@
           <a:lstStyle/>
           <a:p>
             <a:pPr algn="ctr"/>
-            <a:endParaRPr/>
           </a:p>
         </p:txBody>
       </p:sp>
@@ -9530,7 +9407,7 @@
           </a:fontRef>
         </p:style>
         <p:txBody>
-          <a:bodyPr wrap="square" rtlCol="0" anchor="ctr"/>
+          <a:bodyPr rtlCol="0" anchor="ctr" wrap="square"/>
           <a:lstStyle/>
           <a:p>
             <a:pPr algn="ctr">
@@ -9590,7 +9467,7 @@
           </a:fontRef>
         </p:style>
         <p:txBody>
-          <a:bodyPr wrap="square" rtlCol="0" anchor="ctr"/>
+          <a:bodyPr rtlCol="0" anchor="ctr" wrap="square"/>
           <a:lstStyle/>
           <a:p>
             <a:pPr algn="ctr">
@@ -9650,7 +9527,7 @@
           </a:fontRef>
         </p:style>
         <p:txBody>
-          <a:bodyPr wrap="square" rtlCol="0" anchor="ctr"/>
+          <a:bodyPr rtlCol="0" anchor="ctr" wrap="square"/>
           <a:lstStyle/>
           <a:p>
             <a:pPr algn="ctr">
@@ -9710,7 +9587,7 @@
           </a:fontRef>
         </p:style>
         <p:txBody>
-          <a:bodyPr wrap="square" rtlCol="0" anchor="ctr"/>
+          <a:bodyPr rtlCol="0" anchor="ctr" wrap="square"/>
           <a:lstStyle/>
           <a:p>
             <a:pPr algn="ctr">
@@ -9770,7 +9647,7 @@
           </a:fontRef>
         </p:style>
         <p:txBody>
-          <a:bodyPr wrap="square" rtlCol="0" anchor="ctr"/>
+          <a:bodyPr rtlCol="0" anchor="ctr" wrap="square"/>
           <a:lstStyle/>
           <a:p>
             <a:pPr algn="ctr">
@@ -9830,7 +9707,7 @@
           </a:fontRef>
         </p:style>
         <p:txBody>
-          <a:bodyPr wrap="square" rtlCol="0" anchor="ctr"/>
+          <a:bodyPr rtlCol="0" anchor="ctr" wrap="square"/>
           <a:lstStyle/>
           <a:p>
             <a:pPr algn="ctr">
@@ -9960,7 +9837,7 @@
           </a:fontRef>
         </p:style>
         <p:txBody>
-          <a:bodyPr wrap="square" rtlCol="0" anchor="ctr"/>
+          <a:bodyPr rtlCol="0" anchor="ctr" wrap="square"/>
           <a:lstStyle/>
           <a:p>
             <a:pPr algn="ctr">
@@ -10090,7 +9967,7 @@
           </a:fontRef>
         </p:style>
         <p:txBody>
-          <a:bodyPr wrap="square" rtlCol="0" anchor="ctr"/>
+          <a:bodyPr rtlCol="0" anchor="ctr" wrap="square"/>
           <a:lstStyle/>
           <a:p>
             <a:pPr algn="ctr">
@@ -10154,7 +10031,6 @@
           <a:lstStyle/>
           <a:p>
             <a:pPr algn="ctr"/>
-            <a:endParaRPr/>
           </a:p>
         </p:txBody>
       </p:sp>
@@ -10198,7 +10074,6 @@
           <a:lstStyle/>
           <a:p>
             <a:pPr algn="ctr"/>
-            <a:endParaRPr/>
           </a:p>
         </p:txBody>
       </p:sp>
@@ -10285,7 +10160,7 @@
 </file>
 
 <file path=ppt/slides/slide6.xml><?xml version="1.0" encoding="utf-8"?>
-<p:sld xmlns:a="http://schemas.openxmlformats.org/drawingml/2006/main" xmlns:r="http://schemas.openxmlformats.org/officeDocument/2006/relationships" xmlns:p="http://schemas.openxmlformats.org/presentationml/2006/main">
+<p:sld xmlns:a="http://schemas.openxmlformats.org/drawingml/2006/main" xmlns:p="http://schemas.openxmlformats.org/presentationml/2006/main" xmlns:r="http://schemas.openxmlformats.org/officeDocument/2006/relationships">
   <p:cSld>
     <p:bg>
       <p:bgPr>
@@ -10301,14 +10176,7 @@
         <p:cNvGrpSpPr/>
         <p:nvPr/>
       </p:nvGrpSpPr>
-      <p:grpSpPr>
-        <a:xfrm>
-          <a:off x="0" y="0"/>
-          <a:ext cx="0" cy="0"/>
-          <a:chOff x="0" y="0"/>
-          <a:chExt cx="0" cy="0"/>
-        </a:xfrm>
-      </p:grpSpPr>
+      <p:grpSpPr/>
       <p:sp>
         <p:nvSpPr>
           <p:cNvPr id="2" name="TextBox 1"/>
@@ -10662,7 +10530,7 @@
           </a:fontRef>
         </p:style>
         <p:txBody>
-          <a:bodyPr wrap="square" lIns="182880" tIns="137160" rIns="137160" bIns="91440" rtlCol="0" anchor="ctr"/>
+          <a:bodyPr rtlCol="0" anchor="ctr" wrap="square" lIns="182880" rIns="137160" tIns="137160" bIns="91440"/>
           <a:lstStyle/>
           <a:p>
             <a:pPr algn="ctr">
@@ -10777,7 +10645,7 @@
           </a:fontRef>
         </p:style>
         <p:txBody>
-          <a:bodyPr wrap="square" lIns="182880" tIns="109728" bIns="109728" rtlCol="0" anchor="ctr"/>
+          <a:bodyPr rtlCol="0" anchor="ctr" wrap="square" lIns="182880" tIns="109728" bIns="109728"/>
           <a:lstStyle/>
           <a:p>
             <a:pPr algn="ctr">
@@ -10869,7 +10737,7 @@
 </file>
 
 <file path=ppt/slides/slide7.xml><?xml version="1.0" encoding="utf-8"?>
-<p:sld xmlns:a="http://schemas.openxmlformats.org/drawingml/2006/main" xmlns:r="http://schemas.openxmlformats.org/officeDocument/2006/relationships" xmlns:p="http://schemas.openxmlformats.org/presentationml/2006/main">
+<p:sld xmlns:a="http://schemas.openxmlformats.org/drawingml/2006/main" xmlns:p="http://schemas.openxmlformats.org/presentationml/2006/main" xmlns:r="http://schemas.openxmlformats.org/officeDocument/2006/relationships">
   <p:cSld>
     <p:bg>
       <p:bgPr>
@@ -10885,14 +10753,7 @@
         <p:cNvGrpSpPr/>
         <p:nvPr/>
       </p:nvGrpSpPr>
-      <p:grpSpPr>
-        <a:xfrm>
-          <a:off x="0" y="0"/>
-          <a:ext cx="0" cy="0"/>
-          <a:chOff x="0" y="0"/>
-          <a:chExt cx="0" cy="0"/>
-        </a:xfrm>
-      </p:grpSpPr>
+      <p:grpSpPr/>
       <p:sp>
         <p:nvSpPr>
           <p:cNvPr id="2" name="TextBox 1"/>
@@ -11007,7 +10868,7 @@
 </file>
 
 <file path=ppt/slides/slide8.xml><?xml version="1.0" encoding="utf-8"?>
-<p:sld xmlns:a="http://schemas.openxmlformats.org/drawingml/2006/main" xmlns:r="http://schemas.openxmlformats.org/officeDocument/2006/relationships" xmlns:p="http://schemas.openxmlformats.org/presentationml/2006/main">
+<p:sld xmlns:a="http://schemas.openxmlformats.org/drawingml/2006/main" xmlns:p="http://schemas.openxmlformats.org/presentationml/2006/main" xmlns:r="http://schemas.openxmlformats.org/officeDocument/2006/relationships">
   <p:cSld>
     <p:bg>
       <p:bgPr>
@@ -11023,14 +10884,7 @@
         <p:cNvGrpSpPr/>
         <p:nvPr/>
       </p:nvGrpSpPr>
-      <p:grpSpPr>
-        <a:xfrm>
-          <a:off x="0" y="0"/>
-          <a:ext cx="0" cy="0"/>
-          <a:chOff x="0" y="0"/>
-          <a:chExt cx="0" cy="0"/>
-        </a:xfrm>
-      </p:grpSpPr>
+      <p:grpSpPr/>
       <p:sp>
         <p:nvSpPr>
           <p:cNvPr id="2" name="TextBox 1"/>
@@ -11139,7 +10993,7 @@
           </a:fontRef>
         </p:style>
         <p:txBody>
-          <a:bodyPr wrap="square" lIns="182880" tIns="137160" rIns="137160" bIns="91440" rtlCol="0" anchor="ctr"/>
+          <a:bodyPr rtlCol="0" anchor="ctr" wrap="square" lIns="182880" rIns="137160" tIns="137160" bIns="91440"/>
           <a:lstStyle/>
           <a:p>
             <a:pPr algn="ctr">
@@ -11316,7 +11170,7 @@
           </a:fontRef>
         </p:style>
         <p:txBody>
-          <a:bodyPr wrap="square" lIns="182880" tIns="137160" rIns="137160" bIns="91440" rtlCol="0" anchor="ctr"/>
+          <a:bodyPr rtlCol="0" anchor="ctr" wrap="square" lIns="182880" rIns="137160" tIns="137160" bIns="91440"/>
           <a:lstStyle/>
           <a:p>
             <a:pPr algn="ctr">
@@ -11496,17 +11350,11 @@
           <p:cNvGraphicFramePr>
             <a:graphicFrameLocks noGrp="1"/>
           </p:cNvGraphicFramePr>
-          <p:nvPr>
-            <p:extLst>
-              <p:ext uri="{D42A27DB-BD31-4B8C-83A1-F6EECF244321}">
-                <p14:modId xmlns:p14="http://schemas.microsoft.com/office/powerpoint/2010/main" val="4134147219"/>
-              </p:ext>
-            </p:extLst>
-          </p:nvPr>
+          <p:nvPr/>
         </p:nvGraphicFramePr>
         <p:xfrm>
-          <a:off x="731520" y="3840481"/>
-          <a:ext cx="6373614" cy="2194562"/>
+          <a:off x="731520" y="3840480"/>
+          <a:ext cx="6949440" cy="2240279"/>
         </p:xfrm>
         <a:graphic>
           <a:graphicData uri="http://schemas.openxmlformats.org/drawingml/2006/table">
@@ -11515,36 +11363,12 @@
                 <a:tableStyleId>{5C22544A-7EE6-4342-B048-85BDC9FD1C3A}</a:tableStyleId>
               </a:tblPr>
               <a:tblGrid>
-                <a:gridCol w="1677267">
-                  <a:extLst>
-                    <a:ext uri="{9D8B030D-6E8A-4147-A177-3AD203B41FA5}">
-                      <a16:colId xmlns:a16="http://schemas.microsoft.com/office/drawing/2014/main" val="20000"/>
-                    </a:ext>
-                  </a:extLst>
-                </a:gridCol>
-                <a:gridCol w="1677267">
-                  <a:extLst>
-                    <a:ext uri="{9D8B030D-6E8A-4147-A177-3AD203B41FA5}">
-                      <a16:colId xmlns:a16="http://schemas.microsoft.com/office/drawing/2014/main" val="20001"/>
-                    </a:ext>
-                  </a:extLst>
-                </a:gridCol>
-                <a:gridCol w="1509540">
-                  <a:extLst>
-                    <a:ext uri="{9D8B030D-6E8A-4147-A177-3AD203B41FA5}">
-                      <a16:colId xmlns:a16="http://schemas.microsoft.com/office/drawing/2014/main" val="20002"/>
-                    </a:ext>
-                  </a:extLst>
-                </a:gridCol>
-                <a:gridCol w="1509540">
-                  <a:extLst>
-                    <a:ext uri="{9D8B030D-6E8A-4147-A177-3AD203B41FA5}">
-                      <a16:colId xmlns:a16="http://schemas.microsoft.com/office/drawing/2014/main" val="20003"/>
-                    </a:ext>
-                  </a:extLst>
-                </a:gridCol>
+                <a:gridCol w="1828800"/>
+                <a:gridCol w="1828800"/>
+                <a:gridCol w="1645920"/>
+                <a:gridCol w="1645920"/>
               </a:tblGrid>
-              <a:tr h="313508">
+              <a:tr h="320039">
                 <a:tc>
                   <a:txBody>
                     <a:bodyPr/>
@@ -11637,13 +11461,8 @@
                     </a:solidFill>
                   </a:tcPr>
                 </a:tc>
-                <a:extLst>
-                  <a:ext uri="{0D108BD9-81ED-4DB2-BD59-A6C34878D82A}">
-                    <a16:rowId xmlns:a16="http://schemas.microsoft.com/office/drawing/2014/main" val="10000"/>
-                  </a:ext>
-                </a:extLst>
               </a:tr>
-              <a:tr h="313508">
+              <a:tr h="320039">
                 <a:tc>
                   <a:txBody>
                     <a:bodyPr/>
@@ -11720,13 +11539,8 @@
                   </a:txBody>
                   <a:tcPr/>
                 </a:tc>
-                <a:extLst>
-                  <a:ext uri="{0D108BD9-81ED-4DB2-BD59-A6C34878D82A}">
-                    <a16:rowId xmlns:a16="http://schemas.microsoft.com/office/drawing/2014/main" val="10001"/>
-                  </a:ext>
-                </a:extLst>
               </a:tr>
-              <a:tr h="313508">
+              <a:tr h="320039">
                 <a:tc>
                   <a:txBody>
                     <a:bodyPr/>
@@ -11803,13 +11617,8 @@
                   </a:txBody>
                   <a:tcPr/>
                 </a:tc>
-                <a:extLst>
-                  <a:ext uri="{0D108BD9-81ED-4DB2-BD59-A6C34878D82A}">
-                    <a16:rowId xmlns:a16="http://schemas.microsoft.com/office/drawing/2014/main" val="10002"/>
-                  </a:ext>
-                </a:extLst>
               </a:tr>
-              <a:tr h="313508">
+              <a:tr h="320039">
                 <a:tc>
                   <a:txBody>
                     <a:bodyPr/>
@@ -11886,13 +11695,8 @@
                   </a:txBody>
                   <a:tcPr/>
                 </a:tc>
-                <a:extLst>
-                  <a:ext uri="{0D108BD9-81ED-4DB2-BD59-A6C34878D82A}">
-                    <a16:rowId xmlns:a16="http://schemas.microsoft.com/office/drawing/2014/main" val="10003"/>
-                  </a:ext>
-                </a:extLst>
               </a:tr>
-              <a:tr h="313508">
+              <a:tr h="320039">
                 <a:tc>
                   <a:txBody>
                     <a:bodyPr/>
@@ -11969,13 +11773,8 @@
                   </a:txBody>
                   <a:tcPr/>
                 </a:tc>
-                <a:extLst>
-                  <a:ext uri="{0D108BD9-81ED-4DB2-BD59-A6C34878D82A}">
-                    <a16:rowId xmlns:a16="http://schemas.microsoft.com/office/drawing/2014/main" val="10004"/>
-                  </a:ext>
-                </a:extLst>
               </a:tr>
-              <a:tr h="313508">
+              <a:tr h="320039">
                 <a:tc>
                   <a:txBody>
                     <a:bodyPr/>
@@ -12052,13 +11851,8 @@
                   </a:txBody>
                   <a:tcPr/>
                 </a:tc>
-                <a:extLst>
-                  <a:ext uri="{0D108BD9-81ED-4DB2-BD59-A6C34878D82A}">
-                    <a16:rowId xmlns:a16="http://schemas.microsoft.com/office/drawing/2014/main" val="10005"/>
-                  </a:ext>
-                </a:extLst>
               </a:tr>
-              <a:tr h="313514">
+              <a:tr h="320045">
                 <a:tc>
                   <a:txBody>
                     <a:bodyPr/>
@@ -12135,11 +11929,6 @@
                   </a:txBody>
                   <a:tcPr/>
                 </a:tc>
-                <a:extLst>
-                  <a:ext uri="{0D108BD9-81ED-4DB2-BD59-A6C34878D82A}">
-                    <a16:rowId xmlns:a16="http://schemas.microsoft.com/office/drawing/2014/main" val="10006"/>
-                  </a:ext>
-                </a:extLst>
               </a:tr>
             </a:tbl>
           </a:graphicData>
@@ -12153,7 +11942,7 @@
         </p:nvSpPr>
         <p:spPr>
           <a:xfrm>
-            <a:off x="7327555" y="3665014"/>
+            <a:off x="6400800" y="3566160"/>
             <a:ext cx="4572000" cy="274320"/>
           </a:xfrm>
           <a:prstGeom prst="rect">
@@ -12186,17 +11975,11 @@
           <p:cNvGraphicFramePr>
             <a:graphicFrameLocks noGrp="1"/>
           </p:cNvGraphicFramePr>
-          <p:nvPr>
-            <p:extLst>
-              <p:ext uri="{D42A27DB-BD31-4B8C-83A1-F6EECF244321}">
-                <p14:modId xmlns:p14="http://schemas.microsoft.com/office/powerpoint/2010/main" val="1599341932"/>
-              </p:ext>
-            </p:extLst>
-          </p:nvPr>
+          <p:nvPr/>
         </p:nvGraphicFramePr>
         <p:xfrm>
-          <a:off x="7401697" y="4206240"/>
-          <a:ext cx="4572000" cy="1763310"/>
+          <a:off x="6400800" y="3840480"/>
+          <a:ext cx="4572000" cy="1600200"/>
         </p:xfrm>
         <a:graphic>
           <a:graphicData uri="http://schemas.openxmlformats.org/drawingml/2006/table">
@@ -12205,29 +11988,11 @@
                 <a:tableStyleId>{5C22544A-7EE6-4342-B048-85BDC9FD1C3A}</a:tableStyleId>
               </a:tblPr>
               <a:tblGrid>
-                <a:gridCol w="1280160">
-                  <a:extLst>
-                    <a:ext uri="{9D8B030D-6E8A-4147-A177-3AD203B41FA5}">
-                      <a16:colId xmlns:a16="http://schemas.microsoft.com/office/drawing/2014/main" val="20000"/>
-                    </a:ext>
-                  </a:extLst>
-                </a:gridCol>
-                <a:gridCol w="1645920">
-                  <a:extLst>
-                    <a:ext uri="{9D8B030D-6E8A-4147-A177-3AD203B41FA5}">
-                      <a16:colId xmlns:a16="http://schemas.microsoft.com/office/drawing/2014/main" val="20001"/>
-                    </a:ext>
-                  </a:extLst>
-                </a:gridCol>
-                <a:gridCol w="1645920">
-                  <a:extLst>
-                    <a:ext uri="{9D8B030D-6E8A-4147-A177-3AD203B41FA5}">
-                      <a16:colId xmlns:a16="http://schemas.microsoft.com/office/drawing/2014/main" val="20002"/>
-                    </a:ext>
-                  </a:extLst>
-                </a:gridCol>
+                <a:gridCol w="1280160"/>
+                <a:gridCol w="1645920"/>
+                <a:gridCol w="1645920"/>
               </a:tblGrid>
-              <a:tr h="352662">
+              <a:tr h="320040">
                 <a:tc>
                   <a:txBody>
                     <a:bodyPr/>
@@ -12297,13 +12062,8 @@
                     </a:solidFill>
                   </a:tcPr>
                 </a:tc>
-                <a:extLst>
-                  <a:ext uri="{0D108BD9-81ED-4DB2-BD59-A6C34878D82A}">
-                    <a16:rowId xmlns:a16="http://schemas.microsoft.com/office/drawing/2014/main" val="10000"/>
-                  </a:ext>
-                </a:extLst>
               </a:tr>
-              <a:tr h="352662">
+              <a:tr h="320040">
                 <a:tc>
                   <a:txBody>
                     <a:bodyPr/>
@@ -12361,13 +12121,8 @@
                   </a:txBody>
                   <a:tcPr/>
                 </a:tc>
-                <a:extLst>
-                  <a:ext uri="{0D108BD9-81ED-4DB2-BD59-A6C34878D82A}">
-                    <a16:rowId xmlns:a16="http://schemas.microsoft.com/office/drawing/2014/main" val="10001"/>
-                  </a:ext>
-                </a:extLst>
               </a:tr>
-              <a:tr h="352662">
+              <a:tr h="320040">
                 <a:tc>
                   <a:txBody>
                     <a:bodyPr/>
@@ -12425,13 +12180,8 @@
                   </a:txBody>
                   <a:tcPr/>
                 </a:tc>
-                <a:extLst>
-                  <a:ext uri="{0D108BD9-81ED-4DB2-BD59-A6C34878D82A}">
-                    <a16:rowId xmlns:a16="http://schemas.microsoft.com/office/drawing/2014/main" val="10002"/>
-                  </a:ext>
-                </a:extLst>
               </a:tr>
-              <a:tr h="352662">
+              <a:tr h="320040">
                 <a:tc>
                   <a:txBody>
                     <a:bodyPr/>
@@ -12489,13 +12239,8 @@
                   </a:txBody>
                   <a:tcPr/>
                 </a:tc>
-                <a:extLst>
-                  <a:ext uri="{0D108BD9-81ED-4DB2-BD59-A6C34878D82A}">
-                    <a16:rowId xmlns:a16="http://schemas.microsoft.com/office/drawing/2014/main" val="10003"/>
-                  </a:ext>
-                </a:extLst>
               </a:tr>
-              <a:tr h="352662">
+              <a:tr h="320040">
                 <a:tc>
                   <a:txBody>
                     <a:bodyPr/>
@@ -12553,11 +12298,6 @@
                   </a:txBody>
                   <a:tcPr/>
                 </a:tc>
-                <a:extLst>
-                  <a:ext uri="{0D108BD9-81ED-4DB2-BD59-A6C34878D82A}">
-                    <a16:rowId xmlns:a16="http://schemas.microsoft.com/office/drawing/2014/main" val="10004"/>
-                  </a:ext>
-                </a:extLst>
               </a:tr>
             </a:tbl>
           </a:graphicData>
@@ -12607,7 +12347,7 @@
 </file>
 
 <file path=ppt/slides/slide9.xml><?xml version="1.0" encoding="utf-8"?>
-<p:sld xmlns:a="http://schemas.openxmlformats.org/drawingml/2006/main" xmlns:r="http://schemas.openxmlformats.org/officeDocument/2006/relationships" xmlns:p="http://schemas.openxmlformats.org/presentationml/2006/main">
+<p:sld xmlns:a="http://schemas.openxmlformats.org/drawingml/2006/main" xmlns:p="http://schemas.openxmlformats.org/presentationml/2006/main" xmlns:r="http://schemas.openxmlformats.org/officeDocument/2006/relationships">
   <p:cSld>
     <p:bg>
       <p:bgPr>
@@ -12623,14 +12363,7 @@
         <p:cNvGrpSpPr/>
         <p:nvPr/>
       </p:nvGrpSpPr>
-      <p:grpSpPr>
-        <a:xfrm>
-          <a:off x="0" y="0"/>
-          <a:ext cx="0" cy="0"/>
-          <a:chOff x="0" y="0"/>
-          <a:chExt cx="0" cy="0"/>
-        </a:xfrm>
-      </p:grpSpPr>
+      <p:grpSpPr/>
       <p:sp>
         <p:nvSpPr>
           <p:cNvPr id="2" name="TextBox 1"/>
@@ -12709,7 +12442,7 @@
         </p:nvSpPr>
         <p:spPr>
           <a:xfrm>
-            <a:off x="731520" y="1920239"/>
+            <a:off x="731520" y="1280160"/>
             <a:ext cx="5303520" cy="1371600"/>
           </a:xfrm>
           <a:prstGeom prst="roundRect">
@@ -12739,7 +12472,7 @@
           </a:fontRef>
         </p:style>
         <p:txBody>
-          <a:bodyPr wrap="square" lIns="182880" tIns="137160" rIns="137160" bIns="91440" rtlCol="0" anchor="ctr"/>
+          <a:bodyPr rtlCol="0" anchor="ctr" wrap="square" lIns="182880" rIns="137160" tIns="137160" bIns="91440"/>
           <a:lstStyle/>
           <a:p>
             <a:pPr algn="ctr">
@@ -12841,7 +12574,7 @@
         </p:nvSpPr>
         <p:spPr>
           <a:xfrm>
-            <a:off x="716280" y="4013473"/>
+            <a:off x="731520" y="2834640"/>
             <a:ext cx="5303520" cy="1097280"/>
           </a:xfrm>
           <a:prstGeom prst="roundRect">
@@ -12871,7 +12604,7 @@
           </a:fontRef>
         </p:style>
         <p:txBody>
-          <a:bodyPr wrap="square" lIns="182880" tIns="137160" rIns="137160" bIns="91440" rtlCol="0" anchor="ctr"/>
+          <a:bodyPr rtlCol="0" anchor="ctr" wrap="square" lIns="182880" rIns="137160" tIns="137160" bIns="91440"/>
           <a:lstStyle/>
           <a:p>
             <a:pPr algn="ctr">
@@ -12973,7 +12706,7 @@
           </a:fontRef>
         </p:style>
         <p:txBody>
-          <a:bodyPr wrap="square" lIns="182880" tIns="137160" rIns="137160" bIns="91440" rtlCol="0" anchor="ctr"/>
+          <a:bodyPr rtlCol="0" anchor="ctr" wrap="square" lIns="182880" rIns="137160" tIns="137160" bIns="91440"/>
           <a:lstStyle/>
           <a:p>
             <a:pPr algn="ctr">
@@ -13090,8 +12823,8 @@
         </p:nvSpPr>
         <p:spPr>
           <a:xfrm>
-            <a:off x="6400800" y="3291839"/>
-            <a:ext cx="5303520" cy="2540549"/>
+            <a:off x="6400800" y="3291840"/>
+            <a:ext cx="5303520" cy="2286000"/>
           </a:xfrm>
           <a:prstGeom prst="roundRect">
             <a:avLst/>
@@ -13124,7 +12857,6 @@
           <a:lstStyle/>
           <a:p>
             <a:pPr algn="ctr"/>
-            <a:endParaRPr/>
           </a:p>
         </p:txBody>
       </p:sp>
@@ -13182,27 +12914,9 @@
                 <a:tableStyleId>{5C22544A-7EE6-4342-B048-85BDC9FD1C3A}</a:tableStyleId>
               </a:tblPr>
               <a:tblGrid>
-                <a:gridCol w="1371600">
-                  <a:extLst>
-                    <a:ext uri="{9D8B030D-6E8A-4147-A177-3AD203B41FA5}">
-                      <a16:colId xmlns:a16="http://schemas.microsoft.com/office/drawing/2014/main" val="20000"/>
-                    </a:ext>
-                  </a:extLst>
-                </a:gridCol>
-                <a:gridCol w="731520">
-                  <a:extLst>
-                    <a:ext uri="{9D8B030D-6E8A-4147-A177-3AD203B41FA5}">
-                      <a16:colId xmlns:a16="http://schemas.microsoft.com/office/drawing/2014/main" val="20001"/>
-                    </a:ext>
-                  </a:extLst>
-                </a:gridCol>
-                <a:gridCol w="2743200">
-                  <a:extLst>
-                    <a:ext uri="{9D8B030D-6E8A-4147-A177-3AD203B41FA5}">
-                      <a16:colId xmlns:a16="http://schemas.microsoft.com/office/drawing/2014/main" val="20002"/>
-                    </a:ext>
-                  </a:extLst>
-                </a:gridCol>
+                <a:gridCol w="1371600"/>
+                <a:gridCol w="731520"/>
+                <a:gridCol w="2743200"/>
               </a:tblGrid>
               <a:tr h="320040">
                 <a:tc>
@@ -13274,11 +12988,6 @@
                     </a:solidFill>
                   </a:tcPr>
                 </a:tc>
-                <a:extLst>
-                  <a:ext uri="{0D108BD9-81ED-4DB2-BD59-A6C34878D82A}">
-                    <a16:rowId xmlns:a16="http://schemas.microsoft.com/office/drawing/2014/main" val="10000"/>
-                  </a:ext>
-                </a:extLst>
               </a:tr>
               <a:tr h="320040">
                 <a:tc>
@@ -13338,11 +13047,6 @@
                   </a:txBody>
                   <a:tcPr/>
                 </a:tc>
-                <a:extLst>
-                  <a:ext uri="{0D108BD9-81ED-4DB2-BD59-A6C34878D82A}">
-                    <a16:rowId xmlns:a16="http://schemas.microsoft.com/office/drawing/2014/main" val="10001"/>
-                  </a:ext>
-                </a:extLst>
               </a:tr>
               <a:tr h="320040">
                 <a:tc>
@@ -13402,11 +13106,6 @@
                   </a:txBody>
                   <a:tcPr/>
                 </a:tc>
-                <a:extLst>
-                  <a:ext uri="{0D108BD9-81ED-4DB2-BD59-A6C34878D82A}">
-                    <a16:rowId xmlns:a16="http://schemas.microsoft.com/office/drawing/2014/main" val="10002"/>
-                  </a:ext>
-                </a:extLst>
               </a:tr>
               <a:tr h="320040">
                 <a:tc>
@@ -13466,11 +13165,6 @@
                   </a:txBody>
                   <a:tcPr/>
                 </a:tc>
-                <a:extLst>
-                  <a:ext uri="{0D108BD9-81ED-4DB2-BD59-A6C34878D82A}">
-                    <a16:rowId xmlns:a16="http://schemas.microsoft.com/office/drawing/2014/main" val="10003"/>
-                  </a:ext>
-                </a:extLst>
               </a:tr>
             </a:tbl>
           </a:graphicData>
@@ -13484,7 +13178,7 @@
         </p:nvSpPr>
         <p:spPr>
           <a:xfrm>
-            <a:off x="6537960" y="4983480"/>
+            <a:off x="6583680" y="4754880"/>
             <a:ext cx="4937760" cy="640080"/>
           </a:xfrm>
           <a:prstGeom prst="roundRect">
@@ -13516,7 +13210,6 @@
           <a:lstStyle/>
           <a:p>
             <a:pPr algn="ctr"/>
-            <a:endParaRPr/>
           </a:p>
         </p:txBody>
       </p:sp>
@@ -13528,7 +13221,7 @@
         </p:nvSpPr>
         <p:spPr>
           <a:xfrm>
-            <a:off x="6720840" y="5212080"/>
+            <a:off x="6766560" y="4846320"/>
             <a:ext cx="4572000" cy="457200"/>
           </a:xfrm>
           <a:prstGeom prst="rect">

</xml_diff>